<commit_message>
Reframe the ask as a 3-year CESI alternance
Slide 8 now asks for a 3-year ingénieur systèmes apprenticeship with
CESI, with the first three months' two-week milestones as proof of
cadence and a three-year arc line. Speaker notes updated, including
an honest answer on how the Hanover protocol was decoded.

Co-Authored-By: Claude Fable 5 <noreply@anthropic.com>
Claude-Session: https://claude.ai/code/session_013n5yGsQZkeJ42KLHNXV8Vp
</commit_message>
<xml_diff>
--- a/presentations/svt-huit-switches.pptx
+++ b/presentations/svt-huit-switches.pptx
@@ -950,7 +950,7 @@
           <a:p>
             <a:r>
               <a:rPr lang="en-US" dirty="0"/>
-              <a:t>Une histoire pour vous montrer jusqu'où va la méthode. Les girouettes : aucune documentation, des trames illisibles à quatre mille huit cents bauds, un checksum inconnu. Des semaines d'écoute sur le bus. Et puis un soir, un glyphe qu'on avait deviné s'affiche sur le panneau. À partir de là, tout devient possible : aujourd'hui la Hanover affiche ce qu'on veut, sans aucun logiciel vendeur. Et un collègue est arrivé aux mêmes conclusions de son côté — deux bancs indépendants, un même protocole. C'est la meilleure preuve qui existe.</a:t>
+              <a:t>Une histoire pour vous montrer jusqu'où va la méthode. Les girouettes : aucune documentation, des trames illisibles à quatre mille huit cents bauds, un checksum inconnu. [Si on me demande comment : on avait le contrôleur sous la main pour écouter le bus — mais personne pour nous expliquer les trames. Tout le décodage, c'est nous.] Et puis un soir, un glyphe qu'on avait deviné s'affiche sur le panneau. À partir de là, tout devient possible : aujourd'hui la Hanover affiche ce qu'on veut, sans aucun logiciel vendeur. Et un collègue est arrivé aux mêmes conclusions de son côté — deux bancs indépendants, un même protocole. C'est la meilleure preuve qui existe.</a:t>
             </a:r>
             <a:endParaRPr lang="en-US" dirty="0"/>
           </a:p>
@@ -1126,7 +1126,7 @@
           <a:p>
             <a:r>
               <a:rPr lang="en-US" dirty="0"/>
-              <a:t>Alors voilà ma demande, très simple : trois mois cadrés, sous forme de stage d'ingénieur systèmes. La promesse des deux semaines, tenue une fois, devient un rythme : un changement mesurable toutes les deux semaines. Semaines un et deux, Stock UC version deux : les listes attendues, pour qu'un manquant se voie avant la fin du chantier — plus jamais huit switches. Ensuite le pilote girouettes de référence, avec le collègue. Puis les rapports en production, avec une vraie mesure d'heures gagnées. Mobitec en natif. Le flux COPIL. Et à la fin : tout est transféré à l'équipe — playbooks, formation, bilan chiffré. Le savoir reste chez SVT.</a:t>
+              <a:t>Alors voilà ma demande : une alternance d'ingénieur systèmes de trois ans, avec le CESI. Pourquoi une alternance ? Parce que ce rythme-là — un changement mesurable toutes les deux semaines — je viens de vous montrer que je le tiens, et l'alternance le rend durable. Voilà les trois premiers mois, semaine par semaine : Stock UC version deux avec les listes attendues — plus jamais huit switches. Le pilote girouettes de référence, avec le collègue. Les rapports en production, avec une vraie mesure d'heures gagnées. Mobitec en natif. Le flux COPIL. Et le transfert à l'équipe. Sur trois ans, on parle d'autre chose : le contrôleur industrialisé, l'usine à rapports en standard sur tous les contrats — et un ingénieur formé chez SVT, qui connaît chaque boîtier de chaque bus. Le CESI encadre, SVT capitalise.</a:t>
             </a:r>
             <a:endParaRPr lang="en-US" dirty="0"/>
           </a:p>
@@ -1214,7 +1214,7 @@
           <a:p>
             <a:r>
               <a:rPr lang="en-US" dirty="0"/>
-              <a:t>Huit switches perdus ont lancé tout ça. Deux semaines ont suffi pour le premier changement. Voyons ce qu'on construit en trois mois. Merci — et si vous voulez, on fait la démonstration maintenant : sortez un téléphone, scannez un code, et regardez la vue COPIL se mettre à jour.</a:t>
+              <a:t>Huit switches perdus ont lancé tout ça. Deux semaines ont suffi pour le premier changement ; trois mois ont construit une chaîne d'outils. Voyons ce qu'on construit en trois ans. Merci — et si vous voulez, on fait la démonstration maintenant : sortez un téléphone, scannez un code, et regardez la vue COPIL se mettre à jour.</a:t>
             </a:r>
             <a:endParaRPr lang="en-US" dirty="0"/>
           </a:p>
@@ -3683,7 +3683,7 @@
         <p:spPr>
           <a:xfrm>
             <a:off x="777240" y="777240"/>
-            <a:ext cx="10607040" cy="1645920"/>
+            <a:ext cx="10972800" cy="1645920"/>
           </a:xfrm>
           <a:prstGeom prst="rect">
             <a:avLst/>
@@ -3697,12 +3697,12 @@
           <a:p>
             <a:pPr indent="0" marL="0">
               <a:lnSpc>
-                <a:spcPts val="5200"/>
+                <a:spcPts val="4800"/>
               </a:lnSpc>
               <a:buNone/>
             </a:pPr>
             <a:r>
-              <a:rPr lang="en-US" sz="4400" b="1" dirty="0">
+              <a:rPr lang="en-US" sz="4000" b="1" dirty="0">
                 <a:solidFill>
                   <a:srgbClr val="EAF2FB"/>
                 </a:solidFill>
@@ -3710,19 +3710,19 @@
                 <a:ea typeface="Calibri" pitchFamily="34" charset="-122"/>
                 <a:cs typeface="Calibri" pitchFamily="34" charset="-120"/>
               </a:rPr>
-              <a:t>Ce que je demande :</a:t>
-            </a:r>
-            <a:endParaRPr lang="en-US" sz="4400" dirty="0"/>
+              <a:t>Ce que je demande : une</a:t>
+            </a:r>
+            <a:endParaRPr lang="en-US" sz="4000" dirty="0"/>
           </a:p>
           <a:p>
             <a:pPr indent="0" marL="0">
               <a:lnSpc>
-                <a:spcPts val="5200"/>
+                <a:spcPts val="4800"/>
               </a:lnSpc>
               <a:buNone/>
             </a:pPr>
             <a:r>
-              <a:rPr lang="en-US" sz="4400" b="1" dirty="0">
+              <a:rPr lang="en-US" sz="4000" b="1" dirty="0">
                 <a:solidFill>
                   <a:srgbClr val="EAF2FB"/>
                 </a:solidFill>
@@ -3730,9 +3730,9 @@
                 <a:ea typeface="Calibri" pitchFamily="34" charset="-122"/>
                 <a:cs typeface="Calibri" pitchFamily="34" charset="-120"/>
               </a:rPr>
-              <a:t>trois mois cadrés.</a:t>
-            </a:r>
-            <a:endParaRPr lang="en-US" sz="4400" dirty="0"/>
+              <a:t>alternance de 3 ans, avec le CESI.</a:t>
+            </a:r>
+            <a:endParaRPr lang="en-US" sz="4000" dirty="0"/>
           </a:p>
         </p:txBody>
       </p:sp>
@@ -3745,7 +3745,7 @@
         <p:spPr>
           <a:xfrm>
             <a:off x="822960" y="2606040"/>
-            <a:ext cx="10424160" cy="457200"/>
+            <a:ext cx="10789920" cy="457200"/>
           </a:xfrm>
           <a:prstGeom prst="rect">
             <a:avLst/>
@@ -3769,7 +3769,7 @@
                 <a:ea typeface="Calibri" pitchFamily="34" charset="-122"/>
                 <a:cs typeface="Calibri" pitchFamily="34" charset="-120"/>
               </a:rPr>
-              <a:t>Un stage d'ingénieur systèmes — un changement mesurable toutes les deux semaines :</a:t>
+              <a:t>Ingénieur systèmes en alternance — et dès les trois premiers mois, un changement mesurable toutes les deux semaines :</a:t>
             </a:r>
             <a:endParaRPr lang="en-US" sz="1600" dirty="0"/>
           </a:p>
@@ -3783,7 +3783,325 @@
         </p:nvSpPr>
         <p:spPr>
           <a:xfrm>
-            <a:off x="822960" y="3200400"/>
+            <a:off x="822960" y="3154680"/>
+            <a:ext cx="10789920" cy="438912"/>
+          </a:xfrm>
+          <a:prstGeom prst="rect">
+            <a:avLst/>
+          </a:prstGeom>
+          <a:noFill/>
+          <a:ln/>
+        </p:spPr>
+        <p:txBody>
+          <a:bodyPr wrap="square" lIns="0" tIns="0" rIns="0" bIns="0" rtlCol="0" anchor="ctr"/>
+          <a:lstStyle/>
+          <a:p>
+            <a:pPr indent="0" marL="0">
+              <a:buNone/>
+            </a:pPr>
+            <a:r>
+              <a:rPr lang="en-US" sz="1450" b="1" dirty="0">
+                <a:solidFill>
+                  <a:srgbClr val="3FCF6E"/>
+                </a:solidFill>
+                <a:latin typeface="Calibri" pitchFamily="34" charset="0"/>
+                <a:ea typeface="Calibri" pitchFamily="34" charset="-122"/>
+                <a:cs typeface="Calibri" pitchFamily="34" charset="-120"/>
+              </a:rPr>
+              <a:t>S1-2</a:t>
+            </a:r>
+            <a:pPr indent="0" marL="0">
+              <a:buNone/>
+            </a:pPr>
+            <a:r>
+              <a:rPr lang="en-US" sz="1450" dirty="0">
+                <a:solidFill>
+                  <a:srgbClr val="EAF2FB"/>
+                </a:solidFill>
+                <a:latin typeface="Calibri" pitchFamily="34" charset="0"/>
+                <a:ea typeface="Calibri" pitchFamily="34" charset="-122"/>
+                <a:cs typeface="Calibri" pitchFamily="34" charset="-120"/>
+              </a:rPr>
+              <a:t>   Stock UC v2 : les listes attendues — un manquant se voit avant la fin du chantier</a:t>
+            </a:r>
+            <a:endParaRPr lang="en-US" sz="1450" dirty="0"/>
+          </a:p>
+        </p:txBody>
+      </p:sp>
+      <p:sp>
+        <p:nvSpPr>
+          <p:cNvPr id="6" name="Text 4"/>
+          <p:cNvSpPr/>
+          <p:nvPr/>
+        </p:nvSpPr>
+        <p:spPr>
+          <a:xfrm>
+            <a:off x="822960" y="3611880"/>
+            <a:ext cx="10789920" cy="438912"/>
+          </a:xfrm>
+          <a:prstGeom prst="rect">
+            <a:avLst/>
+          </a:prstGeom>
+          <a:noFill/>
+          <a:ln/>
+        </p:spPr>
+        <p:txBody>
+          <a:bodyPr wrap="square" lIns="0" tIns="0" rIns="0" bIns="0" rtlCol="0" anchor="ctr"/>
+          <a:lstStyle/>
+          <a:p>
+            <a:pPr indent="0" marL="0">
+              <a:buNone/>
+            </a:pPr>
+            <a:r>
+              <a:rPr lang="en-US" sz="1450" b="1" dirty="0">
+                <a:solidFill>
+                  <a:srgbClr val="3FCF6E"/>
+                </a:solidFill>
+                <a:latin typeface="Calibri" pitchFamily="34" charset="0"/>
+                <a:ea typeface="Calibri" pitchFamily="34" charset="-122"/>
+                <a:cs typeface="Calibri" pitchFamily="34" charset="-120"/>
+              </a:rPr>
+              <a:t>S3-4</a:t>
+            </a:r>
+            <a:pPr indent="0" marL="0">
+              <a:buNone/>
+            </a:pPr>
+            <a:r>
+              <a:rPr lang="en-US" sz="1450" dirty="0">
+                <a:solidFill>
+                  <a:srgbClr val="EAF2FB"/>
+                </a:solidFill>
+                <a:latin typeface="Calibri" pitchFamily="34" charset="0"/>
+                <a:ea typeface="Calibri" pitchFamily="34" charset="-122"/>
+                <a:cs typeface="Calibri" pitchFamily="34" charset="-120"/>
+              </a:rPr>
+              <a:t>   le pilote girouettes de référence, avec le collègue qui a décodé Hanover de son côté</a:t>
+            </a:r>
+            <a:endParaRPr lang="en-US" sz="1450" dirty="0"/>
+          </a:p>
+        </p:txBody>
+      </p:sp>
+      <p:sp>
+        <p:nvSpPr>
+          <p:cNvPr id="7" name="Text 5"/>
+          <p:cNvSpPr/>
+          <p:nvPr/>
+        </p:nvSpPr>
+        <p:spPr>
+          <a:xfrm>
+            <a:off x="822960" y="4069080"/>
+            <a:ext cx="10789920" cy="438912"/>
+          </a:xfrm>
+          <a:prstGeom prst="rect">
+            <a:avLst/>
+          </a:prstGeom>
+          <a:noFill/>
+          <a:ln/>
+        </p:spPr>
+        <p:txBody>
+          <a:bodyPr wrap="square" lIns="0" tIns="0" rIns="0" bIns="0" rtlCol="0" anchor="ctr"/>
+          <a:lstStyle/>
+          <a:p>
+            <a:pPr indent="0" marL="0">
+              <a:buNone/>
+            </a:pPr>
+            <a:r>
+              <a:rPr lang="en-US" sz="1450" b="1" dirty="0">
+                <a:solidFill>
+                  <a:srgbClr val="3FCF6E"/>
+                </a:solidFill>
+                <a:latin typeface="Calibri" pitchFamily="34" charset="0"/>
+                <a:ea typeface="Calibri" pitchFamily="34" charset="-122"/>
+                <a:cs typeface="Calibri" pitchFamily="34" charset="-120"/>
+              </a:rPr>
+              <a:t>S5-6</a:t>
+            </a:r>
+            <a:pPr indent="0" marL="0">
+              <a:buNone/>
+            </a:pPr>
+            <a:r>
+              <a:rPr lang="en-US" sz="1450" dirty="0">
+                <a:solidFill>
+                  <a:srgbClr val="EAF2FB"/>
+                </a:solidFill>
+                <a:latin typeface="Calibri" pitchFamily="34" charset="0"/>
+                <a:ea typeface="Calibri" pitchFamily="34" charset="-122"/>
+                <a:cs typeface="Calibri" pitchFamily="34" charset="-120"/>
+              </a:rPr>
+              <a:t>   les rapports générés en production, avec la métrique heures-par-étude avant / après</a:t>
+            </a:r>
+            <a:endParaRPr lang="en-US" sz="1450" dirty="0"/>
+          </a:p>
+        </p:txBody>
+      </p:sp>
+      <p:sp>
+        <p:nvSpPr>
+          <p:cNvPr id="8" name="Text 6"/>
+          <p:cNvSpPr/>
+          <p:nvPr/>
+        </p:nvSpPr>
+        <p:spPr>
+          <a:xfrm>
+            <a:off x="822960" y="4526280"/>
+            <a:ext cx="10789920" cy="438912"/>
+          </a:xfrm>
+          <a:prstGeom prst="rect">
+            <a:avLst/>
+          </a:prstGeom>
+          <a:noFill/>
+          <a:ln/>
+        </p:spPr>
+        <p:txBody>
+          <a:bodyPr wrap="square" lIns="0" tIns="0" rIns="0" bIns="0" rtlCol="0" anchor="ctr"/>
+          <a:lstStyle/>
+          <a:p>
+            <a:pPr indent="0" marL="0">
+              <a:buNone/>
+            </a:pPr>
+            <a:r>
+              <a:rPr lang="en-US" sz="1450" b="1" dirty="0">
+                <a:solidFill>
+                  <a:srgbClr val="3FCF6E"/>
+                </a:solidFill>
+                <a:latin typeface="Calibri" pitchFamily="34" charset="0"/>
+                <a:ea typeface="Calibri" pitchFamily="34" charset="-122"/>
+                <a:cs typeface="Calibri" pitchFamily="34" charset="-120"/>
+              </a:rPr>
+              <a:t>S7-8</a:t>
+            </a:r>
+            <a:pPr indent="0" marL="0">
+              <a:buNone/>
+            </a:pPr>
+            <a:r>
+              <a:rPr lang="en-US" sz="1450" dirty="0">
+                <a:solidFill>
+                  <a:srgbClr val="EAF2FB"/>
+                </a:solidFill>
+                <a:latin typeface="Calibri" pitchFamily="34" charset="0"/>
+                <a:ea typeface="Calibri" pitchFamily="34" charset="-122"/>
+                <a:cs typeface="Calibri" pitchFamily="34" charset="-120"/>
+              </a:rPr>
+              <a:t>   Mobitec en natif — sortir du mode gabarit</a:t>
+            </a:r>
+            <a:endParaRPr lang="en-US" sz="1450" dirty="0"/>
+          </a:p>
+        </p:txBody>
+      </p:sp>
+      <p:sp>
+        <p:nvSpPr>
+          <p:cNvPr id="9" name="Text 7"/>
+          <p:cNvSpPr/>
+          <p:nvPr/>
+        </p:nvSpPr>
+        <p:spPr>
+          <a:xfrm>
+            <a:off x="822960" y="4983480"/>
+            <a:ext cx="10789920" cy="438912"/>
+          </a:xfrm>
+          <a:prstGeom prst="rect">
+            <a:avLst/>
+          </a:prstGeom>
+          <a:noFill/>
+          <a:ln/>
+        </p:spPr>
+        <p:txBody>
+          <a:bodyPr wrap="square" lIns="0" tIns="0" rIns="0" bIns="0" rtlCol="0" anchor="ctr"/>
+          <a:lstStyle/>
+          <a:p>
+            <a:pPr indent="0" marL="0">
+              <a:buNone/>
+            </a:pPr>
+            <a:r>
+              <a:rPr lang="en-US" sz="1450" b="1" dirty="0">
+                <a:solidFill>
+                  <a:srgbClr val="3FCF6E"/>
+                </a:solidFill>
+                <a:latin typeface="Calibri" pitchFamily="34" charset="0"/>
+                <a:ea typeface="Calibri" pitchFamily="34" charset="-122"/>
+                <a:cs typeface="Calibri" pitchFamily="34" charset="-120"/>
+              </a:rPr>
+              <a:t>S9-10</a:t>
+            </a:r>
+            <a:pPr indent="0" marL="0">
+              <a:buNone/>
+            </a:pPr>
+            <a:r>
+              <a:rPr lang="en-US" sz="1450" dirty="0">
+                <a:solidFill>
+                  <a:srgbClr val="EAF2FB"/>
+                </a:solidFill>
+                <a:latin typeface="Calibri" pitchFamily="34" charset="0"/>
+                <a:ea typeface="Calibri" pitchFamily="34" charset="-122"/>
+                <a:cs typeface="Calibri" pitchFamily="34" charset="-120"/>
+              </a:rPr>
+              <a:t>   le flux et la santé des rapports, en direct dans la routine COPIL</a:t>
+            </a:r>
+            <a:endParaRPr lang="en-US" sz="1450" dirty="0"/>
+          </a:p>
+        </p:txBody>
+      </p:sp>
+      <p:sp>
+        <p:nvSpPr>
+          <p:cNvPr id="10" name="Text 8"/>
+          <p:cNvSpPr/>
+          <p:nvPr/>
+        </p:nvSpPr>
+        <p:spPr>
+          <a:xfrm>
+            <a:off x="822960" y="5440680"/>
+            <a:ext cx="10789920" cy="438912"/>
+          </a:xfrm>
+          <a:prstGeom prst="rect">
+            <a:avLst/>
+          </a:prstGeom>
+          <a:noFill/>
+          <a:ln/>
+        </p:spPr>
+        <p:txBody>
+          <a:bodyPr wrap="square" lIns="0" tIns="0" rIns="0" bIns="0" rtlCol="0" anchor="ctr"/>
+          <a:lstStyle/>
+          <a:p>
+            <a:pPr indent="0" marL="0">
+              <a:buNone/>
+            </a:pPr>
+            <a:r>
+              <a:rPr lang="en-US" sz="1450" b="1" dirty="0">
+                <a:solidFill>
+                  <a:srgbClr val="3FCF6E"/>
+                </a:solidFill>
+                <a:latin typeface="Calibri" pitchFamily="34" charset="0"/>
+                <a:ea typeface="Calibri" pitchFamily="34" charset="-122"/>
+                <a:cs typeface="Calibri" pitchFamily="34" charset="-120"/>
+              </a:rPr>
+              <a:t>S11-12</a:t>
+            </a:r>
+            <a:pPr indent="0" marL="0">
+              <a:buNone/>
+            </a:pPr>
+            <a:r>
+              <a:rPr lang="en-US" sz="1450" dirty="0">
+                <a:solidFill>
+                  <a:srgbClr val="EAF2FB"/>
+                </a:solidFill>
+                <a:latin typeface="Calibri" pitchFamily="34" charset="0"/>
+                <a:ea typeface="Calibri" pitchFamily="34" charset="-122"/>
+                <a:cs typeface="Calibri" pitchFamily="34" charset="-120"/>
+              </a:rPr>
+              <a:t>   transfert à l'équipe : playbooks, formation, bilan chiffré — et premier vol photogrammétrie</a:t>
+            </a:r>
+            <a:endParaRPr lang="en-US" sz="1450" dirty="0"/>
+          </a:p>
+        </p:txBody>
+      </p:sp>
+      <p:sp>
+        <p:nvSpPr>
+          <p:cNvPr id="11" name="Text 9"/>
+          <p:cNvSpPr/>
+          <p:nvPr/>
+        </p:nvSpPr>
+        <p:spPr>
+          <a:xfrm>
+            <a:off x="822960" y="6035040"/>
             <a:ext cx="10789920" cy="457200"/>
           </a:xfrm>
           <a:prstGeom prst="rect">
@@ -3800,294 +4118,15 @@
               <a:buNone/>
             </a:pPr>
             <a:r>
-              <a:rPr lang="en-US" sz="1500" b="1" dirty="0">
-                <a:solidFill>
-                  <a:srgbClr val="3FCF6E"/>
-                </a:solidFill>
-                <a:latin typeface="Calibri" pitchFamily="34" charset="0"/>
-                <a:ea typeface="Calibri" pitchFamily="34" charset="-122"/>
-                <a:cs typeface="Calibri" pitchFamily="34" charset="-120"/>
-              </a:rPr>
-              <a:t>S1-2</a:t>
-            </a:r>
-            <a:pPr indent="0" marL="0">
-              <a:buNone/>
-            </a:pPr>
-            <a:r>
-              <a:rPr lang="en-US" sz="1500" dirty="0">
-                <a:solidFill>
-                  <a:srgbClr val="EAF2FB"/>
-                </a:solidFill>
-                <a:latin typeface="Calibri" pitchFamily="34" charset="0"/>
-                <a:ea typeface="Calibri" pitchFamily="34" charset="-122"/>
-                <a:cs typeface="Calibri" pitchFamily="34" charset="-120"/>
-              </a:rPr>
-              <a:t>   Stock UC v2 : les listes attendues — un manquant se voit avant la fin du chantier</a:t>
-            </a:r>
-            <a:endParaRPr lang="en-US" sz="1500" dirty="0"/>
-          </a:p>
-        </p:txBody>
-      </p:sp>
-      <p:sp>
-        <p:nvSpPr>
-          <p:cNvPr id="6" name="Text 4"/>
-          <p:cNvSpPr/>
-          <p:nvPr/>
-        </p:nvSpPr>
-        <p:spPr>
-          <a:xfrm>
-            <a:off x="822960" y="3703320"/>
-            <a:ext cx="10789920" cy="457200"/>
-          </a:xfrm>
-          <a:prstGeom prst="rect">
-            <a:avLst/>
-          </a:prstGeom>
-          <a:noFill/>
-          <a:ln/>
-        </p:spPr>
-        <p:txBody>
-          <a:bodyPr wrap="square" lIns="0" tIns="0" rIns="0" bIns="0" rtlCol="0" anchor="ctr"/>
-          <a:lstStyle/>
-          <a:p>
-            <a:pPr indent="0" marL="0">
-              <a:buNone/>
-            </a:pPr>
-            <a:r>
-              <a:rPr lang="en-US" sz="1500" b="1" dirty="0">
-                <a:solidFill>
-                  <a:srgbClr val="3FCF6E"/>
-                </a:solidFill>
-                <a:latin typeface="Calibri" pitchFamily="34" charset="0"/>
-                <a:ea typeface="Calibri" pitchFamily="34" charset="-122"/>
-                <a:cs typeface="Calibri" pitchFamily="34" charset="-120"/>
-              </a:rPr>
-              <a:t>S3-4</a:t>
-            </a:r>
-            <a:pPr indent="0" marL="0">
-              <a:buNone/>
-            </a:pPr>
-            <a:r>
-              <a:rPr lang="en-US" sz="1500" dirty="0">
-                <a:solidFill>
-                  <a:srgbClr val="EAF2FB"/>
-                </a:solidFill>
-                <a:latin typeface="Calibri" pitchFamily="34" charset="0"/>
-                <a:ea typeface="Calibri" pitchFamily="34" charset="-122"/>
-                <a:cs typeface="Calibri" pitchFamily="34" charset="-120"/>
-              </a:rPr>
-              <a:t>   le pilote girouettes de référence, avec le collègue qui a décodé Hanover de son côté</a:t>
-            </a:r>
-            <a:endParaRPr lang="en-US" sz="1500" dirty="0"/>
-          </a:p>
-        </p:txBody>
-      </p:sp>
-      <p:sp>
-        <p:nvSpPr>
-          <p:cNvPr id="7" name="Text 5"/>
-          <p:cNvSpPr/>
-          <p:nvPr/>
-        </p:nvSpPr>
-        <p:spPr>
-          <a:xfrm>
-            <a:off x="822960" y="4206240"/>
-            <a:ext cx="10789920" cy="457200"/>
-          </a:xfrm>
-          <a:prstGeom prst="rect">
-            <a:avLst/>
-          </a:prstGeom>
-          <a:noFill/>
-          <a:ln/>
-        </p:spPr>
-        <p:txBody>
-          <a:bodyPr wrap="square" lIns="0" tIns="0" rIns="0" bIns="0" rtlCol="0" anchor="ctr"/>
-          <a:lstStyle/>
-          <a:p>
-            <a:pPr indent="0" marL="0">
-              <a:buNone/>
-            </a:pPr>
-            <a:r>
-              <a:rPr lang="en-US" sz="1500" b="1" dirty="0">
-                <a:solidFill>
-                  <a:srgbClr val="3FCF6E"/>
-                </a:solidFill>
-                <a:latin typeface="Calibri" pitchFamily="34" charset="0"/>
-                <a:ea typeface="Calibri" pitchFamily="34" charset="-122"/>
-                <a:cs typeface="Calibri" pitchFamily="34" charset="-120"/>
-              </a:rPr>
-              <a:t>S5-6</a:t>
-            </a:r>
-            <a:pPr indent="0" marL="0">
-              <a:buNone/>
-            </a:pPr>
-            <a:r>
-              <a:rPr lang="en-US" sz="1500" dirty="0">
-                <a:solidFill>
-                  <a:srgbClr val="EAF2FB"/>
-                </a:solidFill>
-                <a:latin typeface="Calibri" pitchFamily="34" charset="0"/>
-                <a:ea typeface="Calibri" pitchFamily="34" charset="-122"/>
-                <a:cs typeface="Calibri" pitchFamily="34" charset="-120"/>
-              </a:rPr>
-              <a:t>   les rapports générés en production, avec la métrique heures-par-étude avant / après</a:t>
-            </a:r>
-            <a:endParaRPr lang="en-US" sz="1500" dirty="0"/>
-          </a:p>
-        </p:txBody>
-      </p:sp>
-      <p:sp>
-        <p:nvSpPr>
-          <p:cNvPr id="8" name="Text 6"/>
-          <p:cNvSpPr/>
-          <p:nvPr/>
-        </p:nvSpPr>
-        <p:spPr>
-          <a:xfrm>
-            <a:off x="822960" y="4709160"/>
-            <a:ext cx="10789920" cy="457200"/>
-          </a:xfrm>
-          <a:prstGeom prst="rect">
-            <a:avLst/>
-          </a:prstGeom>
-          <a:noFill/>
-          <a:ln/>
-        </p:spPr>
-        <p:txBody>
-          <a:bodyPr wrap="square" lIns="0" tIns="0" rIns="0" bIns="0" rtlCol="0" anchor="ctr"/>
-          <a:lstStyle/>
-          <a:p>
-            <a:pPr indent="0" marL="0">
-              <a:buNone/>
-            </a:pPr>
-            <a:r>
-              <a:rPr lang="en-US" sz="1500" b="1" dirty="0">
-                <a:solidFill>
-                  <a:srgbClr val="3FCF6E"/>
-                </a:solidFill>
-                <a:latin typeface="Calibri" pitchFamily="34" charset="0"/>
-                <a:ea typeface="Calibri" pitchFamily="34" charset="-122"/>
-                <a:cs typeface="Calibri" pitchFamily="34" charset="-120"/>
-              </a:rPr>
-              <a:t>S7-8</a:t>
-            </a:r>
-            <a:pPr indent="0" marL="0">
-              <a:buNone/>
-            </a:pPr>
-            <a:r>
-              <a:rPr lang="en-US" sz="1500" dirty="0">
-                <a:solidFill>
-                  <a:srgbClr val="EAF2FB"/>
-                </a:solidFill>
-                <a:latin typeface="Calibri" pitchFamily="34" charset="0"/>
-                <a:ea typeface="Calibri" pitchFamily="34" charset="-122"/>
-                <a:cs typeface="Calibri" pitchFamily="34" charset="-120"/>
-              </a:rPr>
-              <a:t>   Mobitec en natif — sortir du mode gabarit</a:t>
-            </a:r>
-            <a:endParaRPr lang="en-US" sz="1500" dirty="0"/>
-          </a:p>
-        </p:txBody>
-      </p:sp>
-      <p:sp>
-        <p:nvSpPr>
-          <p:cNvPr id="9" name="Text 7"/>
-          <p:cNvSpPr/>
-          <p:nvPr/>
-        </p:nvSpPr>
-        <p:spPr>
-          <a:xfrm>
-            <a:off x="822960" y="5212080"/>
-            <a:ext cx="10789920" cy="457200"/>
-          </a:xfrm>
-          <a:prstGeom prst="rect">
-            <a:avLst/>
-          </a:prstGeom>
-          <a:noFill/>
-          <a:ln/>
-        </p:spPr>
-        <p:txBody>
-          <a:bodyPr wrap="square" lIns="0" tIns="0" rIns="0" bIns="0" rtlCol="0" anchor="ctr"/>
-          <a:lstStyle/>
-          <a:p>
-            <a:pPr indent="0" marL="0">
-              <a:buNone/>
-            </a:pPr>
-            <a:r>
-              <a:rPr lang="en-US" sz="1500" b="1" dirty="0">
-                <a:solidFill>
-                  <a:srgbClr val="3FCF6E"/>
-                </a:solidFill>
-                <a:latin typeface="Calibri" pitchFamily="34" charset="0"/>
-                <a:ea typeface="Calibri" pitchFamily="34" charset="-122"/>
-                <a:cs typeface="Calibri" pitchFamily="34" charset="-120"/>
-              </a:rPr>
-              <a:t>S9-10</a:t>
-            </a:r>
-            <a:pPr indent="0" marL="0">
-              <a:buNone/>
-            </a:pPr>
-            <a:r>
-              <a:rPr lang="en-US" sz="1500" dirty="0">
-                <a:solidFill>
-                  <a:srgbClr val="EAF2FB"/>
-                </a:solidFill>
-                <a:latin typeface="Calibri" pitchFamily="34" charset="0"/>
-                <a:ea typeface="Calibri" pitchFamily="34" charset="-122"/>
-                <a:cs typeface="Calibri" pitchFamily="34" charset="-120"/>
-              </a:rPr>
-              <a:t>   le flux et la santé des rapports, en direct dans la routine COPIL</a:t>
-            </a:r>
-            <a:endParaRPr lang="en-US" sz="1500" dirty="0"/>
-          </a:p>
-        </p:txBody>
-      </p:sp>
-      <p:sp>
-        <p:nvSpPr>
-          <p:cNvPr id="10" name="Text 8"/>
-          <p:cNvSpPr/>
-          <p:nvPr/>
-        </p:nvSpPr>
-        <p:spPr>
-          <a:xfrm>
-            <a:off x="822960" y="5715000"/>
-            <a:ext cx="10789920" cy="457200"/>
-          </a:xfrm>
-          <a:prstGeom prst="rect">
-            <a:avLst/>
-          </a:prstGeom>
-          <a:noFill/>
-          <a:ln/>
-        </p:spPr>
-        <p:txBody>
-          <a:bodyPr wrap="square" lIns="0" tIns="0" rIns="0" bIns="0" rtlCol="0" anchor="ctr"/>
-          <a:lstStyle/>
-          <a:p>
-            <a:pPr indent="0" marL="0">
-              <a:buNone/>
-            </a:pPr>
-            <a:r>
-              <a:rPr lang="en-US" sz="1500" b="1" dirty="0">
-                <a:solidFill>
-                  <a:srgbClr val="3FCF6E"/>
-                </a:solidFill>
-                <a:latin typeface="Calibri" pitchFamily="34" charset="0"/>
-                <a:ea typeface="Calibri" pitchFamily="34" charset="-122"/>
-                <a:cs typeface="Calibri" pitchFamily="34" charset="-120"/>
-              </a:rPr>
-              <a:t>S11-12</a:t>
-            </a:r>
-            <a:pPr indent="0" marL="0">
-              <a:buNone/>
-            </a:pPr>
-            <a:r>
-              <a:rPr lang="en-US" sz="1500" dirty="0">
-                <a:solidFill>
-                  <a:srgbClr val="EAF2FB"/>
-                </a:solidFill>
-                <a:latin typeface="Calibri" pitchFamily="34" charset="0"/>
-                <a:ea typeface="Calibri" pitchFamily="34" charset="-122"/>
-                <a:cs typeface="Calibri" pitchFamily="34" charset="-120"/>
-              </a:rPr>
-              <a:t>   transfert à l'équipe : playbooks, formation, bilan chiffré — et premier vol photogrammétrie</a:t>
+              <a:rPr lang="en-US" sz="1500" i="1" dirty="0">
+                <a:solidFill>
+                  <a:srgbClr val="4CC3FF"/>
+                </a:solidFill>
+                <a:latin typeface="Calibri" pitchFamily="34" charset="0"/>
+                <a:ea typeface="Calibri" pitchFamily="34" charset="-122"/>
+                <a:cs typeface="Calibri" pitchFamily="34" charset="-120"/>
+              </a:rPr>
+              <a:t>Et sur trois ans : le contrôleur girouettes industrialisé, l'usine à rapports en standard — et un ingénieur formé chez SVT, pour SVT.</a:t>
             </a:r>
             <a:endParaRPr lang="en-US" sz="1500" dirty="0"/>
           </a:p>
@@ -4259,7 +4298,7 @@
                 <a:ea typeface="Calibri" pitchFamily="34" charset="-122"/>
                 <a:cs typeface="Calibri" pitchFamily="34" charset="-120"/>
               </a:rPr>
-              <a:t>Voyons ce qu'on construit en trois mois.</a:t>
+              <a:t>Voyons ce qu'on construit en trois ans.</a:t>
             </a:r>
             <a:endParaRPr lang="en-US" sz="2200" dirty="0"/>
           </a:p>

</xml_diff>

<commit_message>
Add the pupitre / ESP32 visual-interface slide
New slide 7: make the driver's console (the Ucineo UC66/UC67 SAE
pupitre) obey next, by decoding the central-unit-to-console card
exchange so the ESP32 becomes the in-cab visual interface. Framed as
the next bet using the proven capture-decode-replay method; speaker
notes carry the honest caveat that the protocol is not yet captured
and read-only-first discipline. Drone becomes slide 8.

Co-Authored-By: Claude Fable 5 <noreply@anthropic.com>
Claude-Session: https://claude.ai/code/session_013n5yGsQZkeJ42KLHNXV8Vp
</commit_message>
<xml_diff>
--- a/presentations/svt-huit-switches.pptx
+++ b/presentations/svt-huit-switches.pptx
@@ -14,9 +14,10 @@
     <p:sldId id="262" r:id="rId8"/>
     <p:sldId id="263" r:id="rId9"/>
     <p:sldId id="264" r:id="rId10"/>
+    <p:sldId id="265" r:id="rId11"/>
   </p:sldIdLst>
   <p:notesMasterIdLst>
-    <p:notesMasterId r:id="rId11"/>
+    <p:notesMasterId r:id="rId12"/>
   </p:notesMasterIdLst>
   <p:sldSz cx="12192000" cy="6858000"/>
   <p:notesSz cx="6858000" cy="12192000"/>
@@ -552,6 +553,94 @@
 </p:notes>
 </file>
 
+<file path=ppt/notesSlides/notesSlide10.xml><?xml version="1.0" encoding="utf-8"?>
+<p:notes xmlns:a="http://schemas.openxmlformats.org/drawingml/2006/main" xmlns:r="http://schemas.openxmlformats.org/officeDocument/2006/relationships" xmlns:p="http://schemas.openxmlformats.org/presentationml/2006/main">
+  <p:cSld>
+    <p:spTree>
+      <p:nvGrpSpPr>
+        <p:cNvPr id="1" name=""/>
+        <p:cNvGrpSpPr/>
+        <p:nvPr/>
+      </p:nvGrpSpPr>
+      <p:grpSpPr>
+        <a:xfrm>
+          <a:off x="0" y="0"/>
+          <a:ext cx="0" cy="0"/>
+          <a:chOff x="0" y="0"/>
+          <a:chExt cx="0" cy="0"/>
+        </a:xfrm>
+      </p:grpSpPr>
+      <p:sp>
+        <p:nvSpPr>
+          <p:cNvPr id="2" name="Slide Image Placeholder 1"/>
+          <p:cNvSpPr>
+            <a:spLocks noGrp="1" noRot="1" noChangeAspect="1"/>
+          </p:cNvSpPr>
+          <p:nvPr>
+            <p:ph type="sldImg"/>
+          </p:nvPr>
+        </p:nvSpPr>
+        <p:spPr/>
+      </p:sp>
+      <p:sp>
+        <p:nvSpPr>
+          <p:cNvPr id="3" name="Notes Placeholder 2"/>
+          <p:cNvSpPr>
+            <a:spLocks noGrp="1"/>
+          </p:cNvSpPr>
+          <p:nvPr>
+            <p:ph type="body" idx="1"/>
+          </p:nvPr>
+        </p:nvSpPr>
+        <p:spPr/>
+        <p:txBody>
+          <a:bodyPr/>
+          <a:lstStyle/>
+          <a:p>
+            <a:r>
+              <a:rPr lang="en-US" dirty="0"/>
+              <a:t>Huit switches perdus ont lancé tout ça. Deux semaines ont suffi pour le premier changement ; trois mois ont construit une chaîne d'outils. Voyons ce qu'on construit en trois ans. Merci — et si vous voulez, on fait la démonstration maintenant : sortez un téléphone, scannez un code, et regardez la vue COPIL se mettre à jour.</a:t>
+            </a:r>
+            <a:endParaRPr lang="en-US" dirty="0"/>
+          </a:p>
+        </p:txBody>
+      </p:sp>
+      <p:sp>
+        <p:nvSpPr>
+          <p:cNvPr id="4" name="Slide Number Placeholder 3"/>
+          <p:cNvSpPr>
+            <a:spLocks noGrp="1"/>
+          </p:cNvSpPr>
+          <p:nvPr>
+            <p:ph type="sldNum" sz="quarter" idx="10"/>
+          </p:nvPr>
+        </p:nvSpPr>
+        <p:spPr/>
+        <p:txBody>
+          <a:bodyPr/>
+          <a:lstStyle/>
+          <a:p>
+            <a:fld id="{F7021451-1387-4CA6-816F-3879F97B5CBC}" type="slidenum">
+              <a:rPr lang="en-US"/>
+              <a:t>10</a:t>
+            </a:fld>
+            <a:endParaRPr lang="en-US"/>
+          </a:p>
+        </p:txBody>
+      </p:sp>
+    </p:spTree>
+    <p:extLst>
+      <p:ext uri="{BB962C8B-B14F-4D97-AF65-F5344CB8AC3E}">
+        <p14:creationId xmlns:p14="http://schemas.microsoft.com/office/powerpoint/2010/main" val="1024086991"/>
+      </p:ext>
+    </p:extLst>
+  </p:cSld>
+  <p:clrMapOvr>
+    <a:masterClrMapping/>
+  </p:clrMapOvr>
+</p:notes>
+</file>
+
 <file path=ppt/notesSlides/notesSlide2.xml><?xml version="1.0" encoding="utf-8"?>
 <p:notes xmlns:a="http://schemas.openxmlformats.org/drawingml/2006/main" xmlns:r="http://schemas.openxmlformats.org/officeDocument/2006/relationships" xmlns:p="http://schemas.openxmlformats.org/presentationml/2006/main">
   <p:cSld>
@@ -1038,7 +1127,7 @@
           <a:p>
             <a:r>
               <a:rPr lang="en-US" dirty="0"/>
-              <a:t>Et voilà où je veux aller ensuite. Aujourd'hui, une étude de site vit une seule fois : ce qui n'a pas été mesuré ce jour-là est perdu, et chaque cote oubliée coûte un aller-retour. Avec un drone et la photogrammétrie, on reconstruit le site en trois dimensions : on mesure à volonté, on rejoue la visite quand on veut, on simule l'implantation avant de percer. C'est exactement le principe de Stock UC : capturer une fois, correctement, et ne plus jamais perdre l'information. Et on ne part pas de zéro : notre moteur de rapports rend déjà des bus entiers en 3D, et j'ai déjà construit un contrôleur de vol.</a:t>
+              <a:t>Et il y a un autre écran que je veux faire obéir : le pupitre du conducteur. Dans chaque bus, la centrale du SAE — un Ucineo UC66 ou UC67 — pilote la console du conducteur en lui envoyant son écran. Mon pari : cet échange, c'est des composants, des cartes qui s'échangent sur la ligne — donc c'est décodable, exactement comme la girouette. [Soyons honnêtes : on n'a pas encore capturé ce protocole. Ce que j'affirme, c'est la méthode, pas un résultat déjà acquis.] Si on le décode, l'ESP32 se branche sur la ligne et devient l'interface visuelle : un afficheur, un écran de diagnostic embarqué, à nous, sans attendre un vendeur. Et comme toujours : lecture seule d'abord — on écoute avant d'écrire un seul octet.</a:t>
             </a:r>
             <a:endParaRPr lang="en-US" dirty="0"/>
           </a:p>
@@ -1126,7 +1215,7 @@
           <a:p>
             <a:r>
               <a:rPr lang="en-US" dirty="0"/>
-              <a:t>Alors voilà ma demande : une alternance d'ingénieur systèmes de trois ans, avec le CESI. Pourquoi une alternance ? Parce que ce rythme-là — un changement mesurable toutes les deux semaines — je viens de vous montrer que je le tiens, et l'alternance le rend durable. Voilà les trois premiers mois, semaine par semaine : Stock UC version deux avec les listes attendues — plus jamais huit switches. Le pilote girouettes de référence, avec le collègue. Les rapports en production, avec une vraie mesure d'heures gagnées. Mobitec en natif. Le flux COPIL. Et le transfert à l'équipe. Sur trois ans, on parle d'autre chose : le contrôleur industrialisé, l'usine à rapports en standard sur tous les contrats — et un ingénieur formé chez SVT, qui connaît chaque boîtier de chaque bus. Le CESI encadre, SVT capitalise.</a:t>
+              <a:t>Et voilà où je veux aller ensuite. Aujourd'hui, une étude de site vit une seule fois : ce qui n'a pas été mesuré ce jour-là est perdu, et chaque cote oubliée coûte un aller-retour. Avec un drone et la photogrammétrie, on reconstruit le site en trois dimensions : on mesure à volonté, on rejoue la visite quand on veut, on simule l'implantation avant de percer. C'est exactement le principe de Stock UC : capturer une fois, correctement, et ne plus jamais perdre l'information. Et on ne part pas de zéro : notre moteur de rapports rend déjà des bus entiers en 3D, et j'ai déjà construit un contrôleur de vol.</a:t>
             </a:r>
             <a:endParaRPr lang="en-US" dirty="0"/>
           </a:p>
@@ -1214,7 +1303,7 @@
           <a:p>
             <a:r>
               <a:rPr lang="en-US" dirty="0"/>
-              <a:t>Huit switches perdus ont lancé tout ça. Deux semaines ont suffi pour le premier changement ; trois mois ont construit une chaîne d'outils. Voyons ce qu'on construit en trois ans. Merci — et si vous voulez, on fait la démonstration maintenant : sortez un téléphone, scannez un code, et regardez la vue COPIL se mettre à jour.</a:t>
+              <a:t>Alors voilà ma demande : une alternance d'ingénieur systèmes de trois ans, avec le CESI. Pourquoi une alternance ? Parce que ce rythme-là — un changement mesurable toutes les deux semaines — je viens de vous montrer que je le tiens, et l'alternance le rend durable. Voilà les trois premiers mois, semaine par semaine : Stock UC version deux avec les listes attendues — plus jamais huit switches. Le pilote girouettes de référence, avec le collègue. Les rapports en production, avec une vraie mesure d'heures gagnées. Mobitec en natif. Le flux COPIL. Et le transfert à l'équipe. Sur trois ans, on parle d'autre chose : le contrôleur industrialisé, l'usine à rapports en standard sur tous les contrats — et un ingénieur formé chez SVT, qui connaît chaque boîtier de chaque bus. Le CESI encadre, SVT capitalise.</a:t>
             </a:r>
             <a:endParaRPr lang="en-US" dirty="0"/>
           </a:p>
@@ -1735,6 +1824,217 @@
 </p:sld>
 </file>
 
+<file path=ppt/slides/slide10.xml><?xml version="1.0" encoding="utf-8"?>
+<p:sld xmlns:a="http://schemas.openxmlformats.org/drawingml/2006/main" xmlns:r="http://schemas.openxmlformats.org/officeDocument/2006/relationships" xmlns:p="http://schemas.openxmlformats.org/presentationml/2006/main">
+  <p:cSld name="Slide 10">
+    <p:bg>
+      <p:bgPr>
+        <a:solidFill>
+          <a:srgbClr val="0B1626"/>
+        </a:solidFill>
+      </p:bgPr>
+    </p:bg>
+    <p:spTree>
+      <p:nvGrpSpPr>
+        <p:cNvPr id="1" name=""/>
+        <p:cNvGrpSpPr/>
+        <p:nvPr/>
+      </p:nvGrpSpPr>
+      <p:grpSpPr>
+        <a:xfrm>
+          <a:off x="0" y="0"/>
+          <a:ext cx="0" cy="0"/>
+          <a:chOff x="0" y="0"/>
+          <a:chExt cx="0" cy="0"/>
+        </a:xfrm>
+      </p:grpSpPr>
+      <p:sp>
+        <p:nvSpPr>
+          <p:cNvPr id="2" name="Text 0"/>
+          <p:cNvSpPr/>
+          <p:nvPr/>
+        </p:nvSpPr>
+        <p:spPr>
+          <a:xfrm>
+            <a:off x="11521440" y="6446520"/>
+            <a:ext cx="365760" cy="274320"/>
+          </a:xfrm>
+          <a:prstGeom prst="rect">
+            <a:avLst/>
+          </a:prstGeom>
+          <a:noFill/>
+          <a:ln/>
+        </p:spPr>
+        <p:txBody>
+          <a:bodyPr wrap="square" lIns="0" tIns="0" rIns="0" bIns="0" rtlCol="0" anchor="ctr"/>
+          <a:lstStyle/>
+          <a:p>
+            <a:pPr algn="r" indent="0" marL="0">
+              <a:buNone/>
+            </a:pPr>
+            <a:r>
+              <a:rPr lang="en-US" sz="900" dirty="0">
+                <a:solidFill>
+                  <a:srgbClr val="9DB2C7"/>
+                </a:solidFill>
+                <a:latin typeface="Calibri" pitchFamily="34" charset="0"/>
+                <a:ea typeface="Calibri" pitchFamily="34" charset="-122"/>
+                <a:cs typeface="Calibri" pitchFamily="34" charset="-120"/>
+              </a:rPr>
+              <a:t>10</a:t>
+            </a:r>
+            <a:endParaRPr lang="en-US" sz="900" dirty="0"/>
+          </a:p>
+        </p:txBody>
+      </p:sp>
+      <p:sp>
+        <p:nvSpPr>
+          <p:cNvPr id="3" name="Text 1"/>
+          <p:cNvSpPr/>
+          <p:nvPr/>
+        </p:nvSpPr>
+        <p:spPr>
+          <a:xfrm>
+            <a:off x="777240" y="1828800"/>
+            <a:ext cx="10607040" cy="1828800"/>
+          </a:xfrm>
+          <a:prstGeom prst="rect">
+            <a:avLst/>
+          </a:prstGeom>
+          <a:noFill/>
+          <a:ln/>
+        </p:spPr>
+        <p:txBody>
+          <a:bodyPr wrap="square" lIns="0" tIns="0" rIns="0" bIns="0" rtlCol="0" anchor="ctr"/>
+          <a:lstStyle/>
+          <a:p>
+            <a:pPr algn="ctr" indent="0" marL="0">
+              <a:lnSpc>
+                <a:spcPts val="5600"/>
+              </a:lnSpc>
+              <a:buNone/>
+            </a:pPr>
+            <a:r>
+              <a:rPr lang="en-US" sz="4800" b="1" dirty="0">
+                <a:solidFill>
+                  <a:srgbClr val="EAF2FB"/>
+                </a:solidFill>
+                <a:latin typeface="Calibri" pitchFamily="34" charset="0"/>
+                <a:ea typeface="Calibri" pitchFamily="34" charset="-122"/>
+                <a:cs typeface="Calibri" pitchFamily="34" charset="-120"/>
+              </a:rPr>
+              <a:t>Huit switches perdus</a:t>
+            </a:r>
+            <a:endParaRPr lang="en-US" sz="4800" dirty="0"/>
+          </a:p>
+          <a:p>
+            <a:pPr algn="ctr" indent="0" marL="0">
+              <a:lnSpc>
+                <a:spcPts val="5600"/>
+              </a:lnSpc>
+              <a:buNone/>
+            </a:pPr>
+            <a:r>
+              <a:rPr lang="en-US" sz="4800" b="1" dirty="0">
+                <a:solidFill>
+                  <a:srgbClr val="EAF2FB"/>
+                </a:solidFill>
+                <a:latin typeface="Calibri" pitchFamily="34" charset="0"/>
+                <a:ea typeface="Calibri" pitchFamily="34" charset="-122"/>
+                <a:cs typeface="Calibri" pitchFamily="34" charset="-120"/>
+              </a:rPr>
+              <a:t>ont lancé tout ça.</a:t>
+            </a:r>
+            <a:endParaRPr lang="en-US" sz="4800" dirty="0"/>
+          </a:p>
+        </p:txBody>
+      </p:sp>
+      <p:sp>
+        <p:nvSpPr>
+          <p:cNvPr id="4" name="Text 2"/>
+          <p:cNvSpPr/>
+          <p:nvPr/>
+        </p:nvSpPr>
+        <p:spPr>
+          <a:xfrm>
+            <a:off x="822960" y="3931920"/>
+            <a:ext cx="10424160" cy="548640"/>
+          </a:xfrm>
+          <a:prstGeom prst="rect">
+            <a:avLst/>
+          </a:prstGeom>
+          <a:noFill/>
+          <a:ln/>
+        </p:spPr>
+        <p:txBody>
+          <a:bodyPr wrap="square" lIns="0" tIns="0" rIns="0" bIns="0" rtlCol="0" anchor="ctr"/>
+          <a:lstStyle/>
+          <a:p>
+            <a:pPr algn="ctr" indent="0" marL="0">
+              <a:buNone/>
+            </a:pPr>
+            <a:r>
+              <a:rPr lang="en-US" sz="2200" dirty="0">
+                <a:solidFill>
+                  <a:srgbClr val="4CC3FF"/>
+                </a:solidFill>
+                <a:latin typeface="Calibri" pitchFamily="34" charset="0"/>
+                <a:ea typeface="Calibri" pitchFamily="34" charset="-122"/>
+                <a:cs typeface="Calibri" pitchFamily="34" charset="-120"/>
+              </a:rPr>
+              <a:t>Voyons ce qu'on construit en trois ans.</a:t>
+            </a:r>
+            <a:endParaRPr lang="en-US" sz="2200" dirty="0"/>
+          </a:p>
+        </p:txBody>
+      </p:sp>
+      <p:sp>
+        <p:nvSpPr>
+          <p:cNvPr id="5" name="Text 3"/>
+          <p:cNvSpPr/>
+          <p:nvPr/>
+        </p:nvSpPr>
+        <p:spPr>
+          <a:xfrm>
+            <a:off x="822960" y="5577840"/>
+            <a:ext cx="10424160" cy="365760"/>
+          </a:xfrm>
+          <a:prstGeom prst="rect">
+            <a:avLst/>
+          </a:prstGeom>
+          <a:noFill/>
+          <a:ln/>
+        </p:spPr>
+        <p:txBody>
+          <a:bodyPr wrap="square" lIns="0" tIns="0" rIns="0" bIns="0" rtlCol="0" anchor="ctr"/>
+          <a:lstStyle/>
+          <a:p>
+            <a:pPr algn="ctr" indent="0" marL="0">
+              <a:buNone/>
+            </a:pPr>
+            <a:r>
+              <a:rPr lang="en-US" sz="1300" dirty="0">
+                <a:solidFill>
+                  <a:srgbClr val="9DB2C7"/>
+                </a:solidFill>
+                <a:latin typeface="Calibri" pitchFamily="34" charset="0"/>
+                <a:ea typeface="Calibri" pitchFamily="34" charset="-122"/>
+                <a:cs typeface="Calibri" pitchFamily="34" charset="-120"/>
+              </a:rPr>
+              <a:t>Julien Abdou Gonzales  ·  julienabdougonzales@gmail.com  ·  abysse8.github.io</a:t>
+            </a:r>
+            <a:endParaRPr lang="en-US" sz="1300" dirty="0"/>
+          </a:p>
+        </p:txBody>
+      </p:sp>
+    </p:spTree>
+  </p:cSld>
+  <p:clrMapOvr>
+    <a:masterClrMapping/>
+  </p:clrMapOvr>
+</p:sld>
+</file>
+
 <file path=ppt/slides/slide2.xml><?xml version="1.0" encoding="utf-8"?>
 <p:sld xmlns:a="http://schemas.openxmlformats.org/drawingml/2006/main" xmlns:r="http://schemas.openxmlformats.org/officeDocument/2006/relationships" xmlns:p="http://schemas.openxmlformats.org/presentationml/2006/main">
   <p:cSld name="Slide 2">
@@ -3424,7 +3724,7 @@
         </p:nvSpPr>
         <p:spPr>
           <a:xfrm>
-            <a:off x="777240" y="1188720"/>
+            <a:off x="777240" y="685800"/>
             <a:ext cx="10607040" cy="914400"/>
           </a:xfrm>
           <a:prstGeom prst="rect">
@@ -3441,7 +3741,7 @@
               <a:buNone/>
             </a:pPr>
             <a:r>
-              <a:rPr lang="en-US" sz="4400" b="1" dirty="0">
+              <a:rPr lang="en-US" sz="4000" b="1" dirty="0">
                 <a:solidFill>
                   <a:srgbClr val="EAF2FB"/>
                 </a:solidFill>
@@ -3449,9 +3749,9 @@
                 <a:ea typeface="Calibri" pitchFamily="34" charset="-122"/>
                 <a:cs typeface="Calibri" pitchFamily="34" charset="-120"/>
               </a:rPr>
-              <a:t>La suite : voir les sites en 3D.</a:t>
-            </a:r>
-            <a:endParaRPr lang="en-US" sz="4400" dirty="0"/>
+              <a:t>Le prochain écran à faire obéir.</a:t>
+            </a:r>
+            <a:endParaRPr lang="en-US" sz="4000" dirty="0"/>
           </a:p>
         </p:txBody>
       </p:sp>
@@ -3463,24 +3763,171 @@
         </p:nvSpPr>
         <p:spPr>
           <a:xfrm>
-            <a:off x="822960" y="2377440"/>
-            <a:ext cx="10424160" cy="1005840"/>
-          </a:xfrm>
-          <a:prstGeom prst="rect">
-            <a:avLst/>
-          </a:prstGeom>
-          <a:noFill/>
-          <a:ln/>
-        </p:spPr>
-        <p:txBody>
-          <a:bodyPr wrap="square" lIns="0" tIns="0" rIns="0" bIns="0" rtlCol="0" anchor="ctr"/>
-          <a:lstStyle/>
-          <a:p>
-            <a:pPr indent="0" marL="0">
-              <a:buNone/>
-            </a:pPr>
-            <a:r>
-              <a:rPr lang="en-US" sz="1800" dirty="0">
+            <a:off x="822960" y="1508760"/>
+            <a:ext cx="10424160" cy="457200"/>
+          </a:xfrm>
+          <a:prstGeom prst="rect">
+            <a:avLst/>
+          </a:prstGeom>
+          <a:noFill/>
+          <a:ln/>
+        </p:spPr>
+        <p:txBody>
+          <a:bodyPr wrap="square" lIns="0" tIns="0" rIns="0" bIns="0" rtlCol="0" anchor="ctr"/>
+          <a:lstStyle/>
+          <a:p>
+            <a:pPr indent="0" marL="0">
+              <a:buNone/>
+            </a:pPr>
+            <a:r>
+              <a:rPr lang="en-US" sz="1600" dirty="0">
+                <a:solidFill>
+                  <a:srgbClr val="9DB2C7"/>
+                </a:solidFill>
+                <a:latin typeface="Calibri" pitchFamily="34" charset="0"/>
+                <a:ea typeface="Calibri" pitchFamily="34" charset="-122"/>
+                <a:cs typeface="Calibri" pitchFamily="34" charset="-120"/>
+              </a:rPr>
+              <a:t>Le pupitre du conducteur — la console du SAE Ucineo, dans chaque bus.</a:t>
+            </a:r>
+            <a:endParaRPr lang="en-US" sz="1600" dirty="0"/>
+          </a:p>
+        </p:txBody>
+      </p:sp>
+      <p:sp>
+        <p:nvSpPr>
+          <p:cNvPr id="5" name="Shape 3"/>
+          <p:cNvSpPr/>
+          <p:nvPr/>
+        </p:nvSpPr>
+        <p:spPr>
+          <a:xfrm>
+            <a:off x="1051560" y="2514600"/>
+            <a:ext cx="3200400" cy="1325880"/>
+          </a:xfrm>
+          <a:prstGeom prst="roundRect">
+            <a:avLst>
+              <a:gd name="adj" fmla="val 6207"/>
+            </a:avLst>
+          </a:prstGeom>
+          <a:solidFill>
+            <a:srgbClr val="13273D"/>
+          </a:solidFill>
+          <a:ln w="9525">
+            <a:solidFill>
+              <a:srgbClr val="2C4A6B"/>
+            </a:solidFill>
+            <a:prstDash val="solid"/>
+          </a:ln>
+        </p:spPr>
+      </p:sp>
+      <p:sp>
+        <p:nvSpPr>
+          <p:cNvPr id="6" name="Shape 4"/>
+          <p:cNvSpPr/>
+          <p:nvPr/>
+        </p:nvSpPr>
+        <p:spPr>
+          <a:xfrm>
+            <a:off x="7909560" y="2514600"/>
+            <a:ext cx="3200400" cy="1325880"/>
+          </a:xfrm>
+          <a:prstGeom prst="roundRect">
+            <a:avLst>
+              <a:gd name="adj" fmla="val 6207"/>
+            </a:avLst>
+          </a:prstGeom>
+          <a:solidFill>
+            <a:srgbClr val="13273D"/>
+          </a:solidFill>
+          <a:ln w="9525">
+            <a:solidFill>
+              <a:srgbClr val="2C4A6B"/>
+            </a:solidFill>
+            <a:prstDash val="solid"/>
+          </a:ln>
+        </p:spPr>
+      </p:sp>
+      <p:sp>
+        <p:nvSpPr>
+          <p:cNvPr id="7" name="Text 5"/>
+          <p:cNvSpPr/>
+          <p:nvPr/>
+        </p:nvSpPr>
+        <p:spPr>
+          <a:xfrm>
+            <a:off x="1051560" y="2770632"/>
+            <a:ext cx="3200400" cy="914400"/>
+          </a:xfrm>
+          <a:prstGeom prst="rect">
+            <a:avLst/>
+          </a:prstGeom>
+          <a:noFill/>
+          <a:ln/>
+        </p:spPr>
+        <p:txBody>
+          <a:bodyPr wrap="square" lIns="0" tIns="0" rIns="0" bIns="0" rtlCol="0" anchor="ctr"/>
+          <a:lstStyle/>
+          <a:p>
+            <a:pPr algn="ctr" indent="0" marL="0">
+              <a:buNone/>
+            </a:pPr>
+            <a:r>
+              <a:rPr lang="en-US" sz="2000" b="1" dirty="0">
+                <a:solidFill>
+                  <a:srgbClr val="4CC3FF"/>
+                </a:solidFill>
+                <a:latin typeface="Calibri" pitchFamily="34" charset="0"/>
+                <a:ea typeface="Calibri" pitchFamily="34" charset="-122"/>
+                <a:cs typeface="Calibri" pitchFamily="34" charset="-120"/>
+              </a:rPr>
+              <a:t>SAE UCINEO
+</a:t>
+            </a:r>
+            <a:pPr algn="ctr" indent="0" marL="0">
+              <a:buNone/>
+            </a:pPr>
+            <a:r>
+              <a:rPr lang="en-US" sz="1300" dirty="0">
+                <a:solidFill>
+                  <a:srgbClr val="9DB2C7"/>
+                </a:solidFill>
+                <a:latin typeface="Calibri" pitchFamily="34" charset="0"/>
+                <a:ea typeface="Calibri" pitchFamily="34" charset="-122"/>
+                <a:cs typeface="Calibri" pitchFamily="34" charset="-120"/>
+              </a:rPr>
+              <a:t>UC66 / UC67 — la centrale</a:t>
+            </a:r>
+            <a:endParaRPr lang="en-US" sz="2000" dirty="0"/>
+          </a:p>
+        </p:txBody>
+      </p:sp>
+      <p:sp>
+        <p:nvSpPr>
+          <p:cNvPr id="8" name="Text 6"/>
+          <p:cNvSpPr/>
+          <p:nvPr/>
+        </p:nvSpPr>
+        <p:spPr>
+          <a:xfrm>
+            <a:off x="7909560" y="2770632"/>
+            <a:ext cx="3200400" cy="914400"/>
+          </a:xfrm>
+          <a:prstGeom prst="rect">
+            <a:avLst/>
+          </a:prstGeom>
+          <a:noFill/>
+          <a:ln/>
+        </p:spPr>
+        <p:txBody>
+          <a:bodyPr wrap="square" lIns="0" tIns="0" rIns="0" bIns="0" rtlCol="0" anchor="ctr"/>
+          <a:lstStyle/>
+          <a:p>
+            <a:pPr algn="ctr" indent="0" marL="0">
+              <a:buNone/>
+            </a:pPr>
+            <a:r>
+              <a:rPr lang="en-US" sz="2000" b="1" dirty="0">
                 <a:solidFill>
                   <a:srgbClr val="EAF2FB"/>
                 </a:solidFill>
@@ -3488,16 +3935,195 @@
                 <a:ea typeface="Calibri" pitchFamily="34" charset="-122"/>
                 <a:cs typeface="Calibri" pitchFamily="34" charset="-120"/>
               </a:rPr>
-              <a:t>Un drone photographie le site, la photogrammétrie en reconstruit un jumeau 3D.</a:t>
-            </a:r>
-            <a:endParaRPr lang="en-US" sz="1800" dirty="0"/>
-          </a:p>
-          <a:p>
-            <a:pPr indent="0" marL="0">
-              <a:buNone/>
-            </a:pPr>
-            <a:r>
-              <a:rPr lang="en-US" sz="1800" dirty="0">
+              <a:t>PUPITRE
+</a:t>
+            </a:r>
+            <a:pPr algn="ctr" indent="0" marL="0">
+              <a:buNone/>
+            </a:pPr>
+            <a:r>
+              <a:rPr lang="en-US" sz="1300" dirty="0">
+                <a:solidFill>
+                  <a:srgbClr val="9DB2C7"/>
+                </a:solidFill>
+                <a:latin typeface="Calibri" pitchFamily="34" charset="0"/>
+                <a:ea typeface="Calibri" pitchFamily="34" charset="-122"/>
+                <a:cs typeface="Calibri" pitchFamily="34" charset="-120"/>
+              </a:rPr>
+              <a:t>l'écran du conducteur</a:t>
+            </a:r>
+            <a:endParaRPr lang="en-US" sz="2000" dirty="0"/>
+          </a:p>
+        </p:txBody>
+      </p:sp>
+      <p:sp>
+        <p:nvSpPr>
+          <p:cNvPr id="9" name="Text 7"/>
+          <p:cNvSpPr/>
+          <p:nvPr/>
+        </p:nvSpPr>
+        <p:spPr>
+          <a:xfrm>
+            <a:off x="4251960" y="2450592"/>
+            <a:ext cx="3657600" cy="320040"/>
+          </a:xfrm>
+          <a:prstGeom prst="rect">
+            <a:avLst/>
+          </a:prstGeom>
+          <a:noFill/>
+          <a:ln/>
+        </p:spPr>
+        <p:txBody>
+          <a:bodyPr wrap="square" lIns="0" tIns="0" rIns="0" bIns="0" rtlCol="0" anchor="ctr"/>
+          <a:lstStyle/>
+          <a:p>
+            <a:pPr algn="ctr" indent="0" marL="0">
+              <a:buNone/>
+            </a:pPr>
+            <a:r>
+              <a:rPr lang="en-US" sz="1250" i="1" dirty="0">
+                <a:solidFill>
+                  <a:srgbClr val="9DB2C7"/>
+                </a:solidFill>
+                <a:latin typeface="Calibri" pitchFamily="34" charset="0"/>
+                <a:ea typeface="Calibri" pitchFamily="34" charset="-122"/>
+                <a:cs typeface="Calibri" pitchFamily="34" charset="-120"/>
+              </a:rPr>
+              <a:t>l'écran = un échange de composants (des cartes)</a:t>
+            </a:r>
+            <a:endParaRPr lang="en-US" sz="1250" dirty="0"/>
+          </a:p>
+        </p:txBody>
+      </p:sp>
+      <p:sp>
+        <p:nvSpPr>
+          <p:cNvPr id="10" name="Text 8"/>
+          <p:cNvSpPr/>
+          <p:nvPr/>
+        </p:nvSpPr>
+        <p:spPr>
+          <a:xfrm>
+            <a:off x="4251960" y="2788920"/>
+            <a:ext cx="3657600" cy="822960"/>
+          </a:xfrm>
+          <a:prstGeom prst="rect">
+            <a:avLst/>
+          </a:prstGeom>
+          <a:noFill/>
+          <a:ln/>
+        </p:spPr>
+        <p:txBody>
+          <a:bodyPr wrap="square" lIns="0" tIns="0" rIns="0" bIns="0" rtlCol="0" anchor="ctr"/>
+          <a:lstStyle/>
+          <a:p>
+            <a:pPr algn="ctr" indent="0" marL="0">
+              <a:buNone/>
+            </a:pPr>
+            <a:r>
+              <a:rPr lang="en-US" sz="4000" b="1" dirty="0">
+                <a:solidFill>
+                  <a:srgbClr val="4CC3FF"/>
+                </a:solidFill>
+                <a:latin typeface="Calibri" pitchFamily="34" charset="0"/>
+                <a:ea typeface="Calibri" pitchFamily="34" charset="-122"/>
+                <a:cs typeface="Calibri" pitchFamily="34" charset="-120"/>
+              </a:rPr>
+              <a:t>⇄</a:t>
+            </a:r>
+            <a:endParaRPr lang="en-US" sz="4000" dirty="0"/>
+          </a:p>
+        </p:txBody>
+      </p:sp>
+      <p:sp>
+        <p:nvSpPr>
+          <p:cNvPr id="11" name="Shape 9"/>
+          <p:cNvSpPr/>
+          <p:nvPr/>
+        </p:nvSpPr>
+        <p:spPr>
+          <a:xfrm>
+            <a:off x="6080760" y="3840480"/>
+            <a:ext cx="0" cy="502920"/>
+          </a:xfrm>
+          <a:prstGeom prst="line">
+            <a:avLst/>
+          </a:prstGeom>
+          <a:noFill/>
+          <a:ln w="19050">
+            <a:solidFill>
+              <a:srgbClr val="3FCF6E"/>
+            </a:solidFill>
+            <a:prstDash val="dash"/>
+          </a:ln>
+        </p:spPr>
+      </p:sp>
+      <p:sp>
+        <p:nvSpPr>
+          <p:cNvPr id="12" name="Shape 10"/>
+          <p:cNvSpPr/>
+          <p:nvPr/>
+        </p:nvSpPr>
+        <p:spPr>
+          <a:xfrm>
+            <a:off x="4709160" y="4343400"/>
+            <a:ext cx="2743200" cy="822960"/>
+          </a:xfrm>
+          <a:prstGeom prst="roundRect">
+            <a:avLst>
+              <a:gd name="adj" fmla="val 10000"/>
+            </a:avLst>
+          </a:prstGeom>
+          <a:solidFill>
+            <a:srgbClr val="12261C"/>
+          </a:solidFill>
+          <a:ln w="12700">
+            <a:solidFill>
+              <a:srgbClr val="3FCF6E"/>
+            </a:solidFill>
+            <a:prstDash val="solid"/>
+          </a:ln>
+        </p:spPr>
+      </p:sp>
+      <p:sp>
+        <p:nvSpPr>
+          <p:cNvPr id="13" name="Text 11"/>
+          <p:cNvSpPr/>
+          <p:nvPr/>
+        </p:nvSpPr>
+        <p:spPr>
+          <a:xfrm>
+            <a:off x="4709160" y="4507992"/>
+            <a:ext cx="2743200" cy="457200"/>
+          </a:xfrm>
+          <a:prstGeom prst="rect">
+            <a:avLst/>
+          </a:prstGeom>
+          <a:noFill/>
+          <a:ln/>
+        </p:spPr>
+        <p:txBody>
+          <a:bodyPr wrap="square" lIns="0" tIns="0" rIns="0" bIns="0" rtlCol="0" anchor="ctr"/>
+          <a:lstStyle/>
+          <a:p>
+            <a:pPr algn="ctr" indent="0" marL="0">
+              <a:buNone/>
+            </a:pPr>
+            <a:r>
+              <a:rPr lang="en-US" sz="1600" b="1" dirty="0">
+                <a:solidFill>
+                  <a:srgbClr val="3FCF6E"/>
+                </a:solidFill>
+                <a:latin typeface="Calibri" pitchFamily="34" charset="0"/>
+                <a:ea typeface="Calibri" pitchFamily="34" charset="-122"/>
+                <a:cs typeface="Calibri" pitchFamily="34" charset="-120"/>
+              </a:rPr>
+              <a:t>ESP32 </a:t>
+            </a:r>
+            <a:pPr algn="ctr" indent="0" marL="0">
+              <a:buNone/>
+            </a:pPr>
+            <a:r>
+              <a:rPr lang="en-US" sz="1300" dirty="0">
                 <a:solidFill>
                   <a:srgbClr val="EAF2FB"/>
                 </a:solidFill>
@@ -3505,38 +4131,91 @@
                 <a:ea typeface="Calibri" pitchFamily="34" charset="-122"/>
                 <a:cs typeface="Calibri" pitchFamily="34" charset="-120"/>
               </a:rPr>
-              <a:t>On mesure à volonté, on rejoue la visite, on simule l'implantation avant de percer le premier trou.</a:t>
-            </a:r>
-            <a:endParaRPr lang="en-US" sz="1800" dirty="0"/>
-          </a:p>
-        </p:txBody>
-      </p:sp>
-      <p:sp>
-        <p:nvSpPr>
-          <p:cNvPr id="5" name="Text 3"/>
-          <p:cNvSpPr/>
-          <p:nvPr/>
-        </p:nvSpPr>
-        <p:spPr>
-          <a:xfrm>
-            <a:off x="822960" y="3931920"/>
-            <a:ext cx="10424160" cy="548640"/>
-          </a:xfrm>
-          <a:prstGeom prst="rect">
-            <a:avLst/>
-          </a:prstGeom>
-          <a:noFill/>
-          <a:ln/>
-        </p:spPr>
-        <p:txBody>
-          <a:bodyPr wrap="square" lIns="0" tIns="0" rIns="0" bIns="0" rtlCol="0" anchor="ctr"/>
-          <a:lstStyle/>
-          <a:p>
-            <a:pPr indent="0" marL="0">
-              <a:buNone/>
-            </a:pPr>
-            <a:r>
-              <a:rPr lang="en-US" sz="1700" i="1" dirty="0">
+              <a:t>— branché sur le bus</a:t>
+            </a:r>
+            <a:endParaRPr lang="en-US" sz="1600" dirty="0"/>
+          </a:p>
+        </p:txBody>
+      </p:sp>
+      <p:sp>
+        <p:nvSpPr>
+          <p:cNvPr id="14" name="Text 12"/>
+          <p:cNvSpPr/>
+          <p:nvPr/>
+        </p:nvSpPr>
+        <p:spPr>
+          <a:xfrm>
+            <a:off x="822960" y="5440680"/>
+            <a:ext cx="10515600" cy="457200"/>
+          </a:xfrm>
+          <a:prstGeom prst="rect">
+            <a:avLst/>
+          </a:prstGeom>
+          <a:noFill/>
+          <a:ln/>
+        </p:spPr>
+        <p:txBody>
+          <a:bodyPr wrap="square" lIns="0" tIns="0" rIns="0" bIns="0" rtlCol="0" anchor="ctr"/>
+          <a:lstStyle/>
+          <a:p>
+            <a:pPr indent="0" marL="0">
+              <a:buNone/>
+            </a:pPr>
+            <a:r>
+              <a:rPr lang="en-US" sz="1700" b="1" dirty="0">
+                <a:solidFill>
+                  <a:srgbClr val="4CC3FF"/>
+                </a:solidFill>
+                <a:latin typeface="Calibri" pitchFamily="34" charset="0"/>
+                <a:ea typeface="Calibri" pitchFamily="34" charset="-122"/>
+                <a:cs typeface="Calibri" pitchFamily="34" charset="-120"/>
+              </a:rPr>
+              <a:t>On décode l'échange → l'ESP32 devient l'interface visuelle. </a:t>
+            </a:r>
+            <a:pPr indent="0" marL="0">
+              <a:buNone/>
+            </a:pPr>
+            <a:r>
+              <a:rPr lang="en-US" sz="1700" dirty="0">
+                <a:solidFill>
+                  <a:srgbClr val="EAF2FB"/>
+                </a:solidFill>
+                <a:latin typeface="Calibri" pitchFamily="34" charset="0"/>
+                <a:ea typeface="Calibri" pitchFamily="34" charset="-122"/>
+                <a:cs typeface="Calibri" pitchFamily="34" charset="-120"/>
+              </a:rPr>
+              <a:t>Un afficheur embarqué, à nous — sans attendre un vendeur.</a:t>
+            </a:r>
+            <a:endParaRPr lang="en-US" sz="1700" dirty="0"/>
+          </a:p>
+        </p:txBody>
+      </p:sp>
+      <p:sp>
+        <p:nvSpPr>
+          <p:cNvPr id="15" name="Text 13"/>
+          <p:cNvSpPr/>
+          <p:nvPr/>
+        </p:nvSpPr>
+        <p:spPr>
+          <a:xfrm>
+            <a:off x="822960" y="6035040"/>
+            <a:ext cx="10515600" cy="365760"/>
+          </a:xfrm>
+          <a:prstGeom prst="rect">
+            <a:avLst/>
+          </a:prstGeom>
+          <a:noFill/>
+          <a:ln/>
+        </p:spPr>
+        <p:txBody>
+          <a:bodyPr wrap="square" lIns="0" tIns="0" rIns="0" bIns="0" rtlCol="0" anchor="ctr"/>
+          <a:lstStyle/>
+          <a:p>
+            <a:pPr indent="0" marL="0">
+              <a:buNone/>
+            </a:pPr>
+            <a:r>
+              <a:rPr lang="en-US" sz="1400" i="1" dirty="0">
                 <a:solidFill>
                   <a:srgbClr val="9DB2C7"/>
                 </a:solidFill>
@@ -3544,60 +4223,7 @@
                 <a:ea typeface="Calibri" pitchFamily="34" charset="-122"/>
                 <a:cs typeface="Calibri" pitchFamily="34" charset="-120"/>
               </a:rPr>
-              <a:t>Le même principe que Stock UC : </a:t>
-            </a:r>
-            <a:pPr indent="0" marL="0">
-              <a:buNone/>
-            </a:pPr>
-            <a:r>
-              <a:rPr lang="en-US" sz="1700" b="1" i="1" dirty="0">
-                <a:solidFill>
-                  <a:srgbClr val="F0B429"/>
-                </a:solidFill>
-                <a:latin typeface="Calibri" pitchFamily="34" charset="0"/>
-                <a:ea typeface="Calibri" pitchFamily="34" charset="-122"/>
-                <a:cs typeface="Calibri" pitchFamily="34" charset="-120"/>
-              </a:rPr>
-              <a:t>capturer une fois, correctement — et ne plus jamais perdre l'information.</a:t>
-            </a:r>
-            <a:endParaRPr lang="en-US" sz="1700" dirty="0"/>
-          </a:p>
-        </p:txBody>
-      </p:sp>
-      <p:sp>
-        <p:nvSpPr>
-          <p:cNvPr id="6" name="Text 4"/>
-          <p:cNvSpPr/>
-          <p:nvPr/>
-        </p:nvSpPr>
-        <p:spPr>
-          <a:xfrm>
-            <a:off x="822960" y="5029200"/>
-            <a:ext cx="10424160" cy="548640"/>
-          </a:xfrm>
-          <a:prstGeom prst="rect">
-            <a:avLst/>
-          </a:prstGeom>
-          <a:noFill/>
-          <a:ln/>
-        </p:spPr>
-        <p:txBody>
-          <a:bodyPr wrap="square" lIns="0" tIns="0" rIns="0" bIns="0" rtlCol="0" anchor="ctr"/>
-          <a:lstStyle/>
-          <a:p>
-            <a:pPr indent="0" marL="0">
-              <a:buNone/>
-            </a:pPr>
-            <a:r>
-              <a:rPr lang="en-US" sz="1400" dirty="0">
-                <a:solidFill>
-                  <a:srgbClr val="9DB2C7"/>
-                </a:solidFill>
-                <a:latin typeface="Calibri" pitchFamily="34" charset="0"/>
-                <a:ea typeface="Calibri" pitchFamily="34" charset="-122"/>
-                <a:cs typeface="Calibri" pitchFamily="34" charset="-120"/>
-              </a:rPr>
-              <a:t>(Notre moteur de rapports rend déjà des bus entiers en 3D. Et le vol, je connais : j'ai construit un contrôleur de vol drone.)</a:t>
+              <a:t>Même méthode que la girouette : écouter, décoder, rejouer — en lecture seule d'abord.</a:t>
             </a:r>
             <a:endParaRPr lang="en-US" sz="1400" dirty="0"/>
           </a:p>
@@ -3682,27 +4308,24 @@
         </p:nvSpPr>
         <p:spPr>
           <a:xfrm>
-            <a:off x="777240" y="777240"/>
-            <a:ext cx="10972800" cy="1645920"/>
-          </a:xfrm>
-          <a:prstGeom prst="rect">
-            <a:avLst/>
-          </a:prstGeom>
-          <a:noFill/>
-          <a:ln/>
-        </p:spPr>
-        <p:txBody>
-          <a:bodyPr wrap="square" lIns="0" tIns="0" rIns="0" bIns="0" rtlCol="0" anchor="ctr"/>
-          <a:lstStyle/>
-          <a:p>
-            <a:pPr indent="0" marL="0">
-              <a:lnSpc>
-                <a:spcPts val="4800"/>
-              </a:lnSpc>
-              <a:buNone/>
-            </a:pPr>
-            <a:r>
-              <a:rPr lang="en-US" sz="4000" b="1" dirty="0">
+            <a:off x="777240" y="1188720"/>
+            <a:ext cx="10607040" cy="914400"/>
+          </a:xfrm>
+          <a:prstGeom prst="rect">
+            <a:avLst/>
+          </a:prstGeom>
+          <a:noFill/>
+          <a:ln/>
+        </p:spPr>
+        <p:txBody>
+          <a:bodyPr wrap="square" lIns="0" tIns="0" rIns="0" bIns="0" rtlCol="0" anchor="ctr"/>
+          <a:lstStyle/>
+          <a:p>
+            <a:pPr indent="0" marL="0">
+              <a:buNone/>
+            </a:pPr>
+            <a:r>
+              <a:rPr lang="en-US" sz="4400" b="1" dirty="0">
                 <a:solidFill>
                   <a:srgbClr val="EAF2FB"/>
                 </a:solidFill>
@@ -3710,19 +4333,38 @@
                 <a:ea typeface="Calibri" pitchFamily="34" charset="-122"/>
                 <a:cs typeface="Calibri" pitchFamily="34" charset="-120"/>
               </a:rPr>
-              <a:t>Ce que je demande : une</a:t>
-            </a:r>
-            <a:endParaRPr lang="en-US" sz="4000" dirty="0"/>
-          </a:p>
-          <a:p>
-            <a:pPr indent="0" marL="0">
-              <a:lnSpc>
-                <a:spcPts val="4800"/>
-              </a:lnSpc>
-              <a:buNone/>
-            </a:pPr>
-            <a:r>
-              <a:rPr lang="en-US" sz="4000" b="1" dirty="0">
+              <a:t>Et voir les sites en 3D.</a:t>
+            </a:r>
+            <a:endParaRPr lang="en-US" sz="4400" dirty="0"/>
+          </a:p>
+        </p:txBody>
+      </p:sp>
+      <p:sp>
+        <p:nvSpPr>
+          <p:cNvPr id="4" name="Text 2"/>
+          <p:cNvSpPr/>
+          <p:nvPr/>
+        </p:nvSpPr>
+        <p:spPr>
+          <a:xfrm>
+            <a:off x="822960" y="2377440"/>
+            <a:ext cx="10424160" cy="1005840"/>
+          </a:xfrm>
+          <a:prstGeom prst="rect">
+            <a:avLst/>
+          </a:prstGeom>
+          <a:noFill/>
+          <a:ln/>
+        </p:spPr>
+        <p:txBody>
+          <a:bodyPr wrap="square" lIns="0" tIns="0" rIns="0" bIns="0" rtlCol="0" anchor="ctr"/>
+          <a:lstStyle/>
+          <a:p>
+            <a:pPr indent="0" marL="0">
+              <a:buNone/>
+            </a:pPr>
+            <a:r>
+              <a:rPr lang="en-US" sz="1800" dirty="0">
                 <a:solidFill>
                   <a:srgbClr val="EAF2FB"/>
                 </a:solidFill>
@@ -3730,38 +4372,55 @@
                 <a:ea typeface="Calibri" pitchFamily="34" charset="-122"/>
                 <a:cs typeface="Calibri" pitchFamily="34" charset="-120"/>
               </a:rPr>
-              <a:t>alternance de 3 ans, avec le CESI.</a:t>
-            </a:r>
-            <a:endParaRPr lang="en-US" sz="4000" dirty="0"/>
-          </a:p>
-        </p:txBody>
-      </p:sp>
-      <p:sp>
-        <p:nvSpPr>
-          <p:cNvPr id="4" name="Text 2"/>
-          <p:cNvSpPr/>
-          <p:nvPr/>
-        </p:nvSpPr>
-        <p:spPr>
-          <a:xfrm>
-            <a:off x="822960" y="2606040"/>
-            <a:ext cx="10789920" cy="457200"/>
-          </a:xfrm>
-          <a:prstGeom prst="rect">
-            <a:avLst/>
-          </a:prstGeom>
-          <a:noFill/>
-          <a:ln/>
-        </p:spPr>
-        <p:txBody>
-          <a:bodyPr wrap="square" lIns="0" tIns="0" rIns="0" bIns="0" rtlCol="0" anchor="ctr"/>
-          <a:lstStyle/>
-          <a:p>
-            <a:pPr indent="0" marL="0">
-              <a:buNone/>
-            </a:pPr>
-            <a:r>
-              <a:rPr lang="en-US" sz="1600" dirty="0">
+              <a:t>Un drone photographie le site, la photogrammétrie en reconstruit un jumeau 3D.</a:t>
+            </a:r>
+            <a:endParaRPr lang="en-US" sz="1800" dirty="0"/>
+          </a:p>
+          <a:p>
+            <a:pPr indent="0" marL="0">
+              <a:buNone/>
+            </a:pPr>
+            <a:r>
+              <a:rPr lang="en-US" sz="1800" dirty="0">
+                <a:solidFill>
+                  <a:srgbClr val="EAF2FB"/>
+                </a:solidFill>
+                <a:latin typeface="Calibri" pitchFamily="34" charset="0"/>
+                <a:ea typeface="Calibri" pitchFamily="34" charset="-122"/>
+                <a:cs typeface="Calibri" pitchFamily="34" charset="-120"/>
+              </a:rPr>
+              <a:t>On mesure à volonté, on rejoue la visite, on simule l'implantation avant de percer le premier trou.</a:t>
+            </a:r>
+            <a:endParaRPr lang="en-US" sz="1800" dirty="0"/>
+          </a:p>
+        </p:txBody>
+      </p:sp>
+      <p:sp>
+        <p:nvSpPr>
+          <p:cNvPr id="5" name="Text 3"/>
+          <p:cNvSpPr/>
+          <p:nvPr/>
+        </p:nvSpPr>
+        <p:spPr>
+          <a:xfrm>
+            <a:off x="822960" y="3931920"/>
+            <a:ext cx="10424160" cy="548640"/>
+          </a:xfrm>
+          <a:prstGeom prst="rect">
+            <a:avLst/>
+          </a:prstGeom>
+          <a:noFill/>
+          <a:ln/>
+        </p:spPr>
+        <p:txBody>
+          <a:bodyPr wrap="square" lIns="0" tIns="0" rIns="0" bIns="0" rtlCol="0" anchor="ctr"/>
+          <a:lstStyle/>
+          <a:p>
+            <a:pPr indent="0" marL="0">
+              <a:buNone/>
+            </a:pPr>
+            <a:r>
+              <a:rPr lang="en-US" sz="1700" i="1" dirty="0">
                 <a:solidFill>
                   <a:srgbClr val="9DB2C7"/>
                 </a:solidFill>
@@ -3769,62 +4428,23 @@
                 <a:ea typeface="Calibri" pitchFamily="34" charset="-122"/>
                 <a:cs typeface="Calibri" pitchFamily="34" charset="-120"/>
               </a:rPr>
-              <a:t>Ingénieur systèmes en alternance — et dès les trois premiers mois, un changement mesurable toutes les deux semaines :</a:t>
-            </a:r>
-            <a:endParaRPr lang="en-US" sz="1600" dirty="0"/>
-          </a:p>
-        </p:txBody>
-      </p:sp>
-      <p:sp>
-        <p:nvSpPr>
-          <p:cNvPr id="5" name="Text 3"/>
-          <p:cNvSpPr/>
-          <p:nvPr/>
-        </p:nvSpPr>
-        <p:spPr>
-          <a:xfrm>
-            <a:off x="822960" y="3154680"/>
-            <a:ext cx="10789920" cy="438912"/>
-          </a:xfrm>
-          <a:prstGeom prst="rect">
-            <a:avLst/>
-          </a:prstGeom>
-          <a:noFill/>
-          <a:ln/>
-        </p:spPr>
-        <p:txBody>
-          <a:bodyPr wrap="square" lIns="0" tIns="0" rIns="0" bIns="0" rtlCol="0" anchor="ctr"/>
-          <a:lstStyle/>
-          <a:p>
-            <a:pPr indent="0" marL="0">
-              <a:buNone/>
-            </a:pPr>
-            <a:r>
-              <a:rPr lang="en-US" sz="1450" b="1" dirty="0">
-                <a:solidFill>
-                  <a:srgbClr val="3FCF6E"/>
-                </a:solidFill>
-                <a:latin typeface="Calibri" pitchFamily="34" charset="0"/>
-                <a:ea typeface="Calibri" pitchFamily="34" charset="-122"/>
-                <a:cs typeface="Calibri" pitchFamily="34" charset="-120"/>
-              </a:rPr>
-              <a:t>S1-2</a:t>
-            </a:r>
-            <a:pPr indent="0" marL="0">
-              <a:buNone/>
-            </a:pPr>
-            <a:r>
-              <a:rPr lang="en-US" sz="1450" dirty="0">
-                <a:solidFill>
-                  <a:srgbClr val="EAF2FB"/>
-                </a:solidFill>
-                <a:latin typeface="Calibri" pitchFamily="34" charset="0"/>
-                <a:ea typeface="Calibri" pitchFamily="34" charset="-122"/>
-                <a:cs typeface="Calibri" pitchFamily="34" charset="-120"/>
-              </a:rPr>
-              <a:t>   Stock UC v2 : les listes attendues — un manquant se voit avant la fin du chantier</a:t>
-            </a:r>
-            <a:endParaRPr lang="en-US" sz="1450" dirty="0"/>
+              <a:t>Le même principe que Stock UC : </a:t>
+            </a:r>
+            <a:pPr indent="0" marL="0">
+              <a:buNone/>
+            </a:pPr>
+            <a:r>
+              <a:rPr lang="en-US" sz="1700" b="1" i="1" dirty="0">
+                <a:solidFill>
+                  <a:srgbClr val="F0B429"/>
+                </a:solidFill>
+                <a:latin typeface="Calibri" pitchFamily="34" charset="0"/>
+                <a:ea typeface="Calibri" pitchFamily="34" charset="-122"/>
+                <a:cs typeface="Calibri" pitchFamily="34" charset="-120"/>
+              </a:rPr>
+              <a:t>capturer une fois, correctement — et ne plus jamais perdre l'information.</a:t>
+            </a:r>
+            <a:endParaRPr lang="en-US" sz="1700" dirty="0"/>
           </a:p>
         </p:txBody>
       </p:sp>
@@ -3836,299 +4456,34 @@
         </p:nvSpPr>
         <p:spPr>
           <a:xfrm>
-            <a:off x="822960" y="3611880"/>
-            <a:ext cx="10789920" cy="438912"/>
-          </a:xfrm>
-          <a:prstGeom prst="rect">
-            <a:avLst/>
-          </a:prstGeom>
-          <a:noFill/>
-          <a:ln/>
-        </p:spPr>
-        <p:txBody>
-          <a:bodyPr wrap="square" lIns="0" tIns="0" rIns="0" bIns="0" rtlCol="0" anchor="ctr"/>
-          <a:lstStyle/>
-          <a:p>
-            <a:pPr indent="0" marL="0">
-              <a:buNone/>
-            </a:pPr>
-            <a:r>
-              <a:rPr lang="en-US" sz="1450" b="1" dirty="0">
-                <a:solidFill>
-                  <a:srgbClr val="3FCF6E"/>
-                </a:solidFill>
-                <a:latin typeface="Calibri" pitchFamily="34" charset="0"/>
-                <a:ea typeface="Calibri" pitchFamily="34" charset="-122"/>
-                <a:cs typeface="Calibri" pitchFamily="34" charset="-120"/>
-              </a:rPr>
-              <a:t>S3-4</a:t>
-            </a:r>
-            <a:pPr indent="0" marL="0">
-              <a:buNone/>
-            </a:pPr>
-            <a:r>
-              <a:rPr lang="en-US" sz="1450" dirty="0">
-                <a:solidFill>
-                  <a:srgbClr val="EAF2FB"/>
-                </a:solidFill>
-                <a:latin typeface="Calibri" pitchFamily="34" charset="0"/>
-                <a:ea typeface="Calibri" pitchFamily="34" charset="-122"/>
-                <a:cs typeface="Calibri" pitchFamily="34" charset="-120"/>
-              </a:rPr>
-              <a:t>   le pilote girouettes de référence, avec le collègue qui a décodé Hanover de son côté</a:t>
-            </a:r>
-            <a:endParaRPr lang="en-US" sz="1450" dirty="0"/>
-          </a:p>
-        </p:txBody>
-      </p:sp>
-      <p:sp>
-        <p:nvSpPr>
-          <p:cNvPr id="7" name="Text 5"/>
-          <p:cNvSpPr/>
-          <p:nvPr/>
-        </p:nvSpPr>
-        <p:spPr>
-          <a:xfrm>
-            <a:off x="822960" y="4069080"/>
-            <a:ext cx="10789920" cy="438912"/>
-          </a:xfrm>
-          <a:prstGeom prst="rect">
-            <a:avLst/>
-          </a:prstGeom>
-          <a:noFill/>
-          <a:ln/>
-        </p:spPr>
-        <p:txBody>
-          <a:bodyPr wrap="square" lIns="0" tIns="0" rIns="0" bIns="0" rtlCol="0" anchor="ctr"/>
-          <a:lstStyle/>
-          <a:p>
-            <a:pPr indent="0" marL="0">
-              <a:buNone/>
-            </a:pPr>
-            <a:r>
-              <a:rPr lang="en-US" sz="1450" b="1" dirty="0">
-                <a:solidFill>
-                  <a:srgbClr val="3FCF6E"/>
-                </a:solidFill>
-                <a:latin typeface="Calibri" pitchFamily="34" charset="0"/>
-                <a:ea typeface="Calibri" pitchFamily="34" charset="-122"/>
-                <a:cs typeface="Calibri" pitchFamily="34" charset="-120"/>
-              </a:rPr>
-              <a:t>S5-6</a:t>
-            </a:r>
-            <a:pPr indent="0" marL="0">
-              <a:buNone/>
-            </a:pPr>
-            <a:r>
-              <a:rPr lang="en-US" sz="1450" dirty="0">
-                <a:solidFill>
-                  <a:srgbClr val="EAF2FB"/>
-                </a:solidFill>
-                <a:latin typeface="Calibri" pitchFamily="34" charset="0"/>
-                <a:ea typeface="Calibri" pitchFamily="34" charset="-122"/>
-                <a:cs typeface="Calibri" pitchFamily="34" charset="-120"/>
-              </a:rPr>
-              <a:t>   les rapports générés en production, avec la métrique heures-par-étude avant / après</a:t>
-            </a:r>
-            <a:endParaRPr lang="en-US" sz="1450" dirty="0"/>
-          </a:p>
-        </p:txBody>
-      </p:sp>
-      <p:sp>
-        <p:nvSpPr>
-          <p:cNvPr id="8" name="Text 6"/>
-          <p:cNvSpPr/>
-          <p:nvPr/>
-        </p:nvSpPr>
-        <p:spPr>
-          <a:xfrm>
-            <a:off x="822960" y="4526280"/>
-            <a:ext cx="10789920" cy="438912"/>
-          </a:xfrm>
-          <a:prstGeom prst="rect">
-            <a:avLst/>
-          </a:prstGeom>
-          <a:noFill/>
-          <a:ln/>
-        </p:spPr>
-        <p:txBody>
-          <a:bodyPr wrap="square" lIns="0" tIns="0" rIns="0" bIns="0" rtlCol="0" anchor="ctr"/>
-          <a:lstStyle/>
-          <a:p>
-            <a:pPr indent="0" marL="0">
-              <a:buNone/>
-            </a:pPr>
-            <a:r>
-              <a:rPr lang="en-US" sz="1450" b="1" dirty="0">
-                <a:solidFill>
-                  <a:srgbClr val="3FCF6E"/>
-                </a:solidFill>
-                <a:latin typeface="Calibri" pitchFamily="34" charset="0"/>
-                <a:ea typeface="Calibri" pitchFamily="34" charset="-122"/>
-                <a:cs typeface="Calibri" pitchFamily="34" charset="-120"/>
-              </a:rPr>
-              <a:t>S7-8</a:t>
-            </a:r>
-            <a:pPr indent="0" marL="0">
-              <a:buNone/>
-            </a:pPr>
-            <a:r>
-              <a:rPr lang="en-US" sz="1450" dirty="0">
-                <a:solidFill>
-                  <a:srgbClr val="EAF2FB"/>
-                </a:solidFill>
-                <a:latin typeface="Calibri" pitchFamily="34" charset="0"/>
-                <a:ea typeface="Calibri" pitchFamily="34" charset="-122"/>
-                <a:cs typeface="Calibri" pitchFamily="34" charset="-120"/>
-              </a:rPr>
-              <a:t>   Mobitec en natif — sortir du mode gabarit</a:t>
-            </a:r>
-            <a:endParaRPr lang="en-US" sz="1450" dirty="0"/>
-          </a:p>
-        </p:txBody>
-      </p:sp>
-      <p:sp>
-        <p:nvSpPr>
-          <p:cNvPr id="9" name="Text 7"/>
-          <p:cNvSpPr/>
-          <p:nvPr/>
-        </p:nvSpPr>
-        <p:spPr>
-          <a:xfrm>
-            <a:off x="822960" y="4983480"/>
-            <a:ext cx="10789920" cy="438912"/>
-          </a:xfrm>
-          <a:prstGeom prst="rect">
-            <a:avLst/>
-          </a:prstGeom>
-          <a:noFill/>
-          <a:ln/>
-        </p:spPr>
-        <p:txBody>
-          <a:bodyPr wrap="square" lIns="0" tIns="0" rIns="0" bIns="0" rtlCol="0" anchor="ctr"/>
-          <a:lstStyle/>
-          <a:p>
-            <a:pPr indent="0" marL="0">
-              <a:buNone/>
-            </a:pPr>
-            <a:r>
-              <a:rPr lang="en-US" sz="1450" b="1" dirty="0">
-                <a:solidFill>
-                  <a:srgbClr val="3FCF6E"/>
-                </a:solidFill>
-                <a:latin typeface="Calibri" pitchFamily="34" charset="0"/>
-                <a:ea typeface="Calibri" pitchFamily="34" charset="-122"/>
-                <a:cs typeface="Calibri" pitchFamily="34" charset="-120"/>
-              </a:rPr>
-              <a:t>S9-10</a:t>
-            </a:r>
-            <a:pPr indent="0" marL="0">
-              <a:buNone/>
-            </a:pPr>
-            <a:r>
-              <a:rPr lang="en-US" sz="1450" dirty="0">
-                <a:solidFill>
-                  <a:srgbClr val="EAF2FB"/>
-                </a:solidFill>
-                <a:latin typeface="Calibri" pitchFamily="34" charset="0"/>
-                <a:ea typeface="Calibri" pitchFamily="34" charset="-122"/>
-                <a:cs typeface="Calibri" pitchFamily="34" charset="-120"/>
-              </a:rPr>
-              <a:t>   le flux et la santé des rapports, en direct dans la routine COPIL</a:t>
-            </a:r>
-            <a:endParaRPr lang="en-US" sz="1450" dirty="0"/>
-          </a:p>
-        </p:txBody>
-      </p:sp>
-      <p:sp>
-        <p:nvSpPr>
-          <p:cNvPr id="10" name="Text 8"/>
-          <p:cNvSpPr/>
-          <p:nvPr/>
-        </p:nvSpPr>
-        <p:spPr>
-          <a:xfrm>
-            <a:off x="822960" y="5440680"/>
-            <a:ext cx="10789920" cy="438912"/>
-          </a:xfrm>
-          <a:prstGeom prst="rect">
-            <a:avLst/>
-          </a:prstGeom>
-          <a:noFill/>
-          <a:ln/>
-        </p:spPr>
-        <p:txBody>
-          <a:bodyPr wrap="square" lIns="0" tIns="0" rIns="0" bIns="0" rtlCol="0" anchor="ctr"/>
-          <a:lstStyle/>
-          <a:p>
-            <a:pPr indent="0" marL="0">
-              <a:buNone/>
-            </a:pPr>
-            <a:r>
-              <a:rPr lang="en-US" sz="1450" b="1" dirty="0">
-                <a:solidFill>
-                  <a:srgbClr val="3FCF6E"/>
-                </a:solidFill>
-                <a:latin typeface="Calibri" pitchFamily="34" charset="0"/>
-                <a:ea typeface="Calibri" pitchFamily="34" charset="-122"/>
-                <a:cs typeface="Calibri" pitchFamily="34" charset="-120"/>
-              </a:rPr>
-              <a:t>S11-12</a:t>
-            </a:r>
-            <a:pPr indent="0" marL="0">
-              <a:buNone/>
-            </a:pPr>
-            <a:r>
-              <a:rPr lang="en-US" sz="1450" dirty="0">
-                <a:solidFill>
-                  <a:srgbClr val="EAF2FB"/>
-                </a:solidFill>
-                <a:latin typeface="Calibri" pitchFamily="34" charset="0"/>
-                <a:ea typeface="Calibri" pitchFamily="34" charset="-122"/>
-                <a:cs typeface="Calibri" pitchFamily="34" charset="-120"/>
-              </a:rPr>
-              <a:t>   transfert à l'équipe : playbooks, formation, bilan chiffré — et premier vol photogrammétrie</a:t>
-            </a:r>
-            <a:endParaRPr lang="en-US" sz="1450" dirty="0"/>
-          </a:p>
-        </p:txBody>
-      </p:sp>
-      <p:sp>
-        <p:nvSpPr>
-          <p:cNvPr id="11" name="Text 9"/>
-          <p:cNvSpPr/>
-          <p:nvPr/>
-        </p:nvSpPr>
-        <p:spPr>
-          <a:xfrm>
-            <a:off x="822960" y="6035040"/>
-            <a:ext cx="10789920" cy="457200"/>
-          </a:xfrm>
-          <a:prstGeom prst="rect">
-            <a:avLst/>
-          </a:prstGeom>
-          <a:noFill/>
-          <a:ln/>
-        </p:spPr>
-        <p:txBody>
-          <a:bodyPr wrap="square" lIns="0" tIns="0" rIns="0" bIns="0" rtlCol="0" anchor="ctr"/>
-          <a:lstStyle/>
-          <a:p>
-            <a:pPr indent="0" marL="0">
-              <a:buNone/>
-            </a:pPr>
-            <a:r>
-              <a:rPr lang="en-US" sz="1500" i="1" dirty="0">
-                <a:solidFill>
-                  <a:srgbClr val="4CC3FF"/>
-                </a:solidFill>
-                <a:latin typeface="Calibri" pitchFamily="34" charset="0"/>
-                <a:ea typeface="Calibri" pitchFamily="34" charset="-122"/>
-                <a:cs typeface="Calibri" pitchFamily="34" charset="-120"/>
-              </a:rPr>
-              <a:t>Et sur trois ans : le contrôleur girouettes industrialisé, l'usine à rapports en standard — et un ingénieur formé chez SVT, pour SVT.</a:t>
-            </a:r>
-            <a:endParaRPr lang="en-US" sz="1500" dirty="0"/>
+            <a:off x="822960" y="5029200"/>
+            <a:ext cx="10424160" cy="548640"/>
+          </a:xfrm>
+          <a:prstGeom prst="rect">
+            <a:avLst/>
+          </a:prstGeom>
+          <a:noFill/>
+          <a:ln/>
+        </p:spPr>
+        <p:txBody>
+          <a:bodyPr wrap="square" lIns="0" tIns="0" rIns="0" bIns="0" rtlCol="0" anchor="ctr"/>
+          <a:lstStyle/>
+          <a:p>
+            <a:pPr indent="0" marL="0">
+              <a:buNone/>
+            </a:pPr>
+            <a:r>
+              <a:rPr lang="en-US" sz="1400" dirty="0">
+                <a:solidFill>
+                  <a:srgbClr val="9DB2C7"/>
+                </a:solidFill>
+                <a:latin typeface="Calibri" pitchFamily="34" charset="0"/>
+                <a:ea typeface="Calibri" pitchFamily="34" charset="-122"/>
+                <a:cs typeface="Calibri" pitchFamily="34" charset="-120"/>
+              </a:rPr>
+              <a:t>(Notre moteur de rapports rend déjà des bus entiers en 3D. Et le vol, je connais : j'ai construit un contrôleur de vol drone.)</a:t>
+            </a:r>
+            <a:endParaRPr lang="en-US" sz="1400" dirty="0"/>
           </a:p>
         </p:txBody>
       </p:sp>
@@ -4211,27 +4566,27 @@
         </p:nvSpPr>
         <p:spPr>
           <a:xfrm>
-            <a:off x="777240" y="1828800"/>
-            <a:ext cx="10607040" cy="1828800"/>
-          </a:xfrm>
-          <a:prstGeom prst="rect">
-            <a:avLst/>
-          </a:prstGeom>
-          <a:noFill/>
-          <a:ln/>
-        </p:spPr>
-        <p:txBody>
-          <a:bodyPr wrap="square" lIns="0" tIns="0" rIns="0" bIns="0" rtlCol="0" anchor="ctr"/>
-          <a:lstStyle/>
-          <a:p>
-            <a:pPr algn="ctr" indent="0" marL="0">
+            <a:off x="777240" y="777240"/>
+            <a:ext cx="10972800" cy="1645920"/>
+          </a:xfrm>
+          <a:prstGeom prst="rect">
+            <a:avLst/>
+          </a:prstGeom>
+          <a:noFill/>
+          <a:ln/>
+        </p:spPr>
+        <p:txBody>
+          <a:bodyPr wrap="square" lIns="0" tIns="0" rIns="0" bIns="0" rtlCol="0" anchor="ctr"/>
+          <a:lstStyle/>
+          <a:p>
+            <a:pPr indent="0" marL="0">
               <a:lnSpc>
-                <a:spcPts val="5600"/>
+                <a:spcPts val="4800"/>
               </a:lnSpc>
               <a:buNone/>
             </a:pPr>
             <a:r>
-              <a:rPr lang="en-US" sz="4800" b="1" dirty="0">
+              <a:rPr lang="en-US" sz="4000" b="1" dirty="0">
                 <a:solidFill>
                   <a:srgbClr val="EAF2FB"/>
                 </a:solidFill>
@@ -4239,19 +4594,19 @@
                 <a:ea typeface="Calibri" pitchFamily="34" charset="-122"/>
                 <a:cs typeface="Calibri" pitchFamily="34" charset="-120"/>
               </a:rPr>
-              <a:t>Huit switches perdus</a:t>
-            </a:r>
-            <a:endParaRPr lang="en-US" sz="4800" dirty="0"/>
-          </a:p>
-          <a:p>
-            <a:pPr algn="ctr" indent="0" marL="0">
+              <a:t>Ce que je demande : une</a:t>
+            </a:r>
+            <a:endParaRPr lang="en-US" sz="4000" dirty="0"/>
+          </a:p>
+          <a:p>
+            <a:pPr indent="0" marL="0">
               <a:lnSpc>
-                <a:spcPts val="5600"/>
+                <a:spcPts val="4800"/>
               </a:lnSpc>
               <a:buNone/>
             </a:pPr>
             <a:r>
-              <a:rPr lang="en-US" sz="4800" b="1" dirty="0">
+              <a:rPr lang="en-US" sz="4000" b="1" dirty="0">
                 <a:solidFill>
                   <a:srgbClr val="EAF2FB"/>
                 </a:solidFill>
@@ -4259,9 +4614,9 @@
                 <a:ea typeface="Calibri" pitchFamily="34" charset="-122"/>
                 <a:cs typeface="Calibri" pitchFamily="34" charset="-120"/>
               </a:rPr>
-              <a:t>ont lancé tout ça.</a:t>
-            </a:r>
-            <a:endParaRPr lang="en-US" sz="4800" dirty="0"/>
+              <a:t>alternance de 3 ans, avec le CESI.</a:t>
+            </a:r>
+            <a:endParaRPr lang="en-US" sz="4000" dirty="0"/>
           </a:p>
         </p:txBody>
       </p:sp>
@@ -4273,24 +4628,381 @@
         </p:nvSpPr>
         <p:spPr>
           <a:xfrm>
-            <a:off x="822960" y="3931920"/>
-            <a:ext cx="10424160" cy="548640"/>
-          </a:xfrm>
-          <a:prstGeom prst="rect">
-            <a:avLst/>
-          </a:prstGeom>
-          <a:noFill/>
-          <a:ln/>
-        </p:spPr>
-        <p:txBody>
-          <a:bodyPr wrap="square" lIns="0" tIns="0" rIns="0" bIns="0" rtlCol="0" anchor="ctr"/>
-          <a:lstStyle/>
-          <a:p>
-            <a:pPr algn="ctr" indent="0" marL="0">
-              <a:buNone/>
-            </a:pPr>
-            <a:r>
-              <a:rPr lang="en-US" sz="2200" dirty="0">
+            <a:off x="822960" y="2606040"/>
+            <a:ext cx="10789920" cy="457200"/>
+          </a:xfrm>
+          <a:prstGeom prst="rect">
+            <a:avLst/>
+          </a:prstGeom>
+          <a:noFill/>
+          <a:ln/>
+        </p:spPr>
+        <p:txBody>
+          <a:bodyPr wrap="square" lIns="0" tIns="0" rIns="0" bIns="0" rtlCol="0" anchor="ctr"/>
+          <a:lstStyle/>
+          <a:p>
+            <a:pPr indent="0" marL="0">
+              <a:buNone/>
+            </a:pPr>
+            <a:r>
+              <a:rPr lang="en-US" sz="1600" dirty="0">
+                <a:solidFill>
+                  <a:srgbClr val="9DB2C7"/>
+                </a:solidFill>
+                <a:latin typeface="Calibri" pitchFamily="34" charset="0"/>
+                <a:ea typeface="Calibri" pitchFamily="34" charset="-122"/>
+                <a:cs typeface="Calibri" pitchFamily="34" charset="-120"/>
+              </a:rPr>
+              <a:t>Ingénieur systèmes en alternance — et dès les trois premiers mois, un changement mesurable toutes les deux semaines :</a:t>
+            </a:r>
+            <a:endParaRPr lang="en-US" sz="1600" dirty="0"/>
+          </a:p>
+        </p:txBody>
+      </p:sp>
+      <p:sp>
+        <p:nvSpPr>
+          <p:cNvPr id="5" name="Text 3"/>
+          <p:cNvSpPr/>
+          <p:nvPr/>
+        </p:nvSpPr>
+        <p:spPr>
+          <a:xfrm>
+            <a:off x="822960" y="3154680"/>
+            <a:ext cx="10789920" cy="438912"/>
+          </a:xfrm>
+          <a:prstGeom prst="rect">
+            <a:avLst/>
+          </a:prstGeom>
+          <a:noFill/>
+          <a:ln/>
+        </p:spPr>
+        <p:txBody>
+          <a:bodyPr wrap="square" lIns="0" tIns="0" rIns="0" bIns="0" rtlCol="0" anchor="ctr"/>
+          <a:lstStyle/>
+          <a:p>
+            <a:pPr indent="0" marL="0">
+              <a:buNone/>
+            </a:pPr>
+            <a:r>
+              <a:rPr lang="en-US" sz="1450" b="1" dirty="0">
+                <a:solidFill>
+                  <a:srgbClr val="3FCF6E"/>
+                </a:solidFill>
+                <a:latin typeface="Calibri" pitchFamily="34" charset="0"/>
+                <a:ea typeface="Calibri" pitchFamily="34" charset="-122"/>
+                <a:cs typeface="Calibri" pitchFamily="34" charset="-120"/>
+              </a:rPr>
+              <a:t>S1-2</a:t>
+            </a:r>
+            <a:pPr indent="0" marL="0">
+              <a:buNone/>
+            </a:pPr>
+            <a:r>
+              <a:rPr lang="en-US" sz="1450" dirty="0">
+                <a:solidFill>
+                  <a:srgbClr val="EAF2FB"/>
+                </a:solidFill>
+                <a:latin typeface="Calibri" pitchFamily="34" charset="0"/>
+                <a:ea typeface="Calibri" pitchFamily="34" charset="-122"/>
+                <a:cs typeface="Calibri" pitchFamily="34" charset="-120"/>
+              </a:rPr>
+              <a:t>   Stock UC v2 : les listes attendues — un manquant se voit avant la fin du chantier</a:t>
+            </a:r>
+            <a:endParaRPr lang="en-US" sz="1450" dirty="0"/>
+          </a:p>
+        </p:txBody>
+      </p:sp>
+      <p:sp>
+        <p:nvSpPr>
+          <p:cNvPr id="6" name="Text 4"/>
+          <p:cNvSpPr/>
+          <p:nvPr/>
+        </p:nvSpPr>
+        <p:spPr>
+          <a:xfrm>
+            <a:off x="822960" y="3611880"/>
+            <a:ext cx="10789920" cy="438912"/>
+          </a:xfrm>
+          <a:prstGeom prst="rect">
+            <a:avLst/>
+          </a:prstGeom>
+          <a:noFill/>
+          <a:ln/>
+        </p:spPr>
+        <p:txBody>
+          <a:bodyPr wrap="square" lIns="0" tIns="0" rIns="0" bIns="0" rtlCol="0" anchor="ctr"/>
+          <a:lstStyle/>
+          <a:p>
+            <a:pPr indent="0" marL="0">
+              <a:buNone/>
+            </a:pPr>
+            <a:r>
+              <a:rPr lang="en-US" sz="1450" b="1" dirty="0">
+                <a:solidFill>
+                  <a:srgbClr val="3FCF6E"/>
+                </a:solidFill>
+                <a:latin typeface="Calibri" pitchFamily="34" charset="0"/>
+                <a:ea typeface="Calibri" pitchFamily="34" charset="-122"/>
+                <a:cs typeface="Calibri" pitchFamily="34" charset="-120"/>
+              </a:rPr>
+              <a:t>S3-4</a:t>
+            </a:r>
+            <a:pPr indent="0" marL="0">
+              <a:buNone/>
+            </a:pPr>
+            <a:r>
+              <a:rPr lang="en-US" sz="1450" dirty="0">
+                <a:solidFill>
+                  <a:srgbClr val="EAF2FB"/>
+                </a:solidFill>
+                <a:latin typeface="Calibri" pitchFamily="34" charset="0"/>
+                <a:ea typeface="Calibri" pitchFamily="34" charset="-122"/>
+                <a:cs typeface="Calibri" pitchFamily="34" charset="-120"/>
+              </a:rPr>
+              <a:t>   le pilote girouettes de référence, avec le collègue qui a décodé Hanover de son côté</a:t>
+            </a:r>
+            <a:endParaRPr lang="en-US" sz="1450" dirty="0"/>
+          </a:p>
+        </p:txBody>
+      </p:sp>
+      <p:sp>
+        <p:nvSpPr>
+          <p:cNvPr id="7" name="Text 5"/>
+          <p:cNvSpPr/>
+          <p:nvPr/>
+        </p:nvSpPr>
+        <p:spPr>
+          <a:xfrm>
+            <a:off x="822960" y="4069080"/>
+            <a:ext cx="10789920" cy="438912"/>
+          </a:xfrm>
+          <a:prstGeom prst="rect">
+            <a:avLst/>
+          </a:prstGeom>
+          <a:noFill/>
+          <a:ln/>
+        </p:spPr>
+        <p:txBody>
+          <a:bodyPr wrap="square" lIns="0" tIns="0" rIns="0" bIns="0" rtlCol="0" anchor="ctr"/>
+          <a:lstStyle/>
+          <a:p>
+            <a:pPr indent="0" marL="0">
+              <a:buNone/>
+            </a:pPr>
+            <a:r>
+              <a:rPr lang="en-US" sz="1450" b="1" dirty="0">
+                <a:solidFill>
+                  <a:srgbClr val="3FCF6E"/>
+                </a:solidFill>
+                <a:latin typeface="Calibri" pitchFamily="34" charset="0"/>
+                <a:ea typeface="Calibri" pitchFamily="34" charset="-122"/>
+                <a:cs typeface="Calibri" pitchFamily="34" charset="-120"/>
+              </a:rPr>
+              <a:t>S5-6</a:t>
+            </a:r>
+            <a:pPr indent="0" marL="0">
+              <a:buNone/>
+            </a:pPr>
+            <a:r>
+              <a:rPr lang="en-US" sz="1450" dirty="0">
+                <a:solidFill>
+                  <a:srgbClr val="EAF2FB"/>
+                </a:solidFill>
+                <a:latin typeface="Calibri" pitchFamily="34" charset="0"/>
+                <a:ea typeface="Calibri" pitchFamily="34" charset="-122"/>
+                <a:cs typeface="Calibri" pitchFamily="34" charset="-120"/>
+              </a:rPr>
+              <a:t>   les rapports générés en production, avec la métrique heures-par-étude avant / après</a:t>
+            </a:r>
+            <a:endParaRPr lang="en-US" sz="1450" dirty="0"/>
+          </a:p>
+        </p:txBody>
+      </p:sp>
+      <p:sp>
+        <p:nvSpPr>
+          <p:cNvPr id="8" name="Text 6"/>
+          <p:cNvSpPr/>
+          <p:nvPr/>
+        </p:nvSpPr>
+        <p:spPr>
+          <a:xfrm>
+            <a:off x="822960" y="4526280"/>
+            <a:ext cx="10789920" cy="438912"/>
+          </a:xfrm>
+          <a:prstGeom prst="rect">
+            <a:avLst/>
+          </a:prstGeom>
+          <a:noFill/>
+          <a:ln/>
+        </p:spPr>
+        <p:txBody>
+          <a:bodyPr wrap="square" lIns="0" tIns="0" rIns="0" bIns="0" rtlCol="0" anchor="ctr"/>
+          <a:lstStyle/>
+          <a:p>
+            <a:pPr indent="0" marL="0">
+              <a:buNone/>
+            </a:pPr>
+            <a:r>
+              <a:rPr lang="en-US" sz="1450" b="1" dirty="0">
+                <a:solidFill>
+                  <a:srgbClr val="3FCF6E"/>
+                </a:solidFill>
+                <a:latin typeface="Calibri" pitchFamily="34" charset="0"/>
+                <a:ea typeface="Calibri" pitchFamily="34" charset="-122"/>
+                <a:cs typeface="Calibri" pitchFamily="34" charset="-120"/>
+              </a:rPr>
+              <a:t>S7-8</a:t>
+            </a:r>
+            <a:pPr indent="0" marL="0">
+              <a:buNone/>
+            </a:pPr>
+            <a:r>
+              <a:rPr lang="en-US" sz="1450" dirty="0">
+                <a:solidFill>
+                  <a:srgbClr val="EAF2FB"/>
+                </a:solidFill>
+                <a:latin typeface="Calibri" pitchFamily="34" charset="0"/>
+                <a:ea typeface="Calibri" pitchFamily="34" charset="-122"/>
+                <a:cs typeface="Calibri" pitchFamily="34" charset="-120"/>
+              </a:rPr>
+              <a:t>   Mobitec en natif — sortir du mode gabarit</a:t>
+            </a:r>
+            <a:endParaRPr lang="en-US" sz="1450" dirty="0"/>
+          </a:p>
+        </p:txBody>
+      </p:sp>
+      <p:sp>
+        <p:nvSpPr>
+          <p:cNvPr id="9" name="Text 7"/>
+          <p:cNvSpPr/>
+          <p:nvPr/>
+        </p:nvSpPr>
+        <p:spPr>
+          <a:xfrm>
+            <a:off x="822960" y="4983480"/>
+            <a:ext cx="10789920" cy="438912"/>
+          </a:xfrm>
+          <a:prstGeom prst="rect">
+            <a:avLst/>
+          </a:prstGeom>
+          <a:noFill/>
+          <a:ln/>
+        </p:spPr>
+        <p:txBody>
+          <a:bodyPr wrap="square" lIns="0" tIns="0" rIns="0" bIns="0" rtlCol="0" anchor="ctr"/>
+          <a:lstStyle/>
+          <a:p>
+            <a:pPr indent="0" marL="0">
+              <a:buNone/>
+            </a:pPr>
+            <a:r>
+              <a:rPr lang="en-US" sz="1450" b="1" dirty="0">
+                <a:solidFill>
+                  <a:srgbClr val="3FCF6E"/>
+                </a:solidFill>
+                <a:latin typeface="Calibri" pitchFamily="34" charset="0"/>
+                <a:ea typeface="Calibri" pitchFamily="34" charset="-122"/>
+                <a:cs typeface="Calibri" pitchFamily="34" charset="-120"/>
+              </a:rPr>
+              <a:t>S9-10</a:t>
+            </a:r>
+            <a:pPr indent="0" marL="0">
+              <a:buNone/>
+            </a:pPr>
+            <a:r>
+              <a:rPr lang="en-US" sz="1450" dirty="0">
+                <a:solidFill>
+                  <a:srgbClr val="EAF2FB"/>
+                </a:solidFill>
+                <a:latin typeface="Calibri" pitchFamily="34" charset="0"/>
+                <a:ea typeface="Calibri" pitchFamily="34" charset="-122"/>
+                <a:cs typeface="Calibri" pitchFamily="34" charset="-120"/>
+              </a:rPr>
+              <a:t>   le flux et la santé des rapports, en direct dans la routine COPIL</a:t>
+            </a:r>
+            <a:endParaRPr lang="en-US" sz="1450" dirty="0"/>
+          </a:p>
+        </p:txBody>
+      </p:sp>
+      <p:sp>
+        <p:nvSpPr>
+          <p:cNvPr id="10" name="Text 8"/>
+          <p:cNvSpPr/>
+          <p:nvPr/>
+        </p:nvSpPr>
+        <p:spPr>
+          <a:xfrm>
+            <a:off x="822960" y="5440680"/>
+            <a:ext cx="10789920" cy="438912"/>
+          </a:xfrm>
+          <a:prstGeom prst="rect">
+            <a:avLst/>
+          </a:prstGeom>
+          <a:noFill/>
+          <a:ln/>
+        </p:spPr>
+        <p:txBody>
+          <a:bodyPr wrap="square" lIns="0" tIns="0" rIns="0" bIns="0" rtlCol="0" anchor="ctr"/>
+          <a:lstStyle/>
+          <a:p>
+            <a:pPr indent="0" marL="0">
+              <a:buNone/>
+            </a:pPr>
+            <a:r>
+              <a:rPr lang="en-US" sz="1450" b="1" dirty="0">
+                <a:solidFill>
+                  <a:srgbClr val="3FCF6E"/>
+                </a:solidFill>
+                <a:latin typeface="Calibri" pitchFamily="34" charset="0"/>
+                <a:ea typeface="Calibri" pitchFamily="34" charset="-122"/>
+                <a:cs typeface="Calibri" pitchFamily="34" charset="-120"/>
+              </a:rPr>
+              <a:t>S11-12</a:t>
+            </a:r>
+            <a:pPr indent="0" marL="0">
+              <a:buNone/>
+            </a:pPr>
+            <a:r>
+              <a:rPr lang="en-US" sz="1450" dirty="0">
+                <a:solidFill>
+                  <a:srgbClr val="EAF2FB"/>
+                </a:solidFill>
+                <a:latin typeface="Calibri" pitchFamily="34" charset="0"/>
+                <a:ea typeface="Calibri" pitchFamily="34" charset="-122"/>
+                <a:cs typeface="Calibri" pitchFamily="34" charset="-120"/>
+              </a:rPr>
+              <a:t>   transfert à l'équipe : playbooks, formation, bilan chiffré — et premier vol photogrammétrie</a:t>
+            </a:r>
+            <a:endParaRPr lang="en-US" sz="1450" dirty="0"/>
+          </a:p>
+        </p:txBody>
+      </p:sp>
+      <p:sp>
+        <p:nvSpPr>
+          <p:cNvPr id="11" name="Text 9"/>
+          <p:cNvSpPr/>
+          <p:nvPr/>
+        </p:nvSpPr>
+        <p:spPr>
+          <a:xfrm>
+            <a:off x="822960" y="6035040"/>
+            <a:ext cx="10789920" cy="457200"/>
+          </a:xfrm>
+          <a:prstGeom prst="rect">
+            <a:avLst/>
+          </a:prstGeom>
+          <a:noFill/>
+          <a:ln/>
+        </p:spPr>
+        <p:txBody>
+          <a:bodyPr wrap="square" lIns="0" tIns="0" rIns="0" bIns="0" rtlCol="0" anchor="ctr"/>
+          <a:lstStyle/>
+          <a:p>
+            <a:pPr indent="0" marL="0">
+              <a:buNone/>
+            </a:pPr>
+            <a:r>
+              <a:rPr lang="en-US" sz="1500" i="1" dirty="0">
                 <a:solidFill>
                   <a:srgbClr val="4CC3FF"/>
                 </a:solidFill>
@@ -4298,48 +5010,9 @@
                 <a:ea typeface="Calibri" pitchFamily="34" charset="-122"/>
                 <a:cs typeface="Calibri" pitchFamily="34" charset="-120"/>
               </a:rPr>
-              <a:t>Voyons ce qu'on construit en trois ans.</a:t>
-            </a:r>
-            <a:endParaRPr lang="en-US" sz="2200" dirty="0"/>
-          </a:p>
-        </p:txBody>
-      </p:sp>
-      <p:sp>
-        <p:nvSpPr>
-          <p:cNvPr id="5" name="Text 3"/>
-          <p:cNvSpPr/>
-          <p:nvPr/>
-        </p:nvSpPr>
-        <p:spPr>
-          <a:xfrm>
-            <a:off x="822960" y="5577840"/>
-            <a:ext cx="10424160" cy="365760"/>
-          </a:xfrm>
-          <a:prstGeom prst="rect">
-            <a:avLst/>
-          </a:prstGeom>
-          <a:noFill/>
-          <a:ln/>
-        </p:spPr>
-        <p:txBody>
-          <a:bodyPr wrap="square" lIns="0" tIns="0" rIns="0" bIns="0" rtlCol="0" anchor="ctr"/>
-          <a:lstStyle/>
-          <a:p>
-            <a:pPr algn="ctr" indent="0" marL="0">
-              <a:buNone/>
-            </a:pPr>
-            <a:r>
-              <a:rPr lang="en-US" sz="1300" dirty="0">
-                <a:solidFill>
-                  <a:srgbClr val="9DB2C7"/>
-                </a:solidFill>
-                <a:latin typeface="Calibri" pitchFamily="34" charset="0"/>
-                <a:ea typeface="Calibri" pitchFamily="34" charset="-122"/>
-                <a:cs typeface="Calibri" pitchFamily="34" charset="-120"/>
-              </a:rPr>
-              <a:t>Julien Abdou Gonzales  ·  julienabdougonzales@gmail.com  ·  abysse8.github.io</a:t>
-            </a:r>
-            <a:endParaRPr lang="en-US" sz="1300" dirty="0"/>
+              <a:t>Et sur trois ans : le contrôleur girouettes industrialisé, l'usine à rapports en standard — et un ingénieur formé chez SVT, pour SVT.</a:t>
+            </a:r>
+            <a:endParaRPr lang="en-US" sz="1500" dirty="0"/>
           </a:p>
         </p:txBody>
       </p:sp>

</xml_diff>